<commit_message>
Show UkilRAG cells as compact ideas with example outputs
</commit_message>
<xml_diff>
--- a/presentation/Nafis_Ismam_Docitalis_Final.pptx
+++ b/presentation/Nafis_Ismam_Docitalis_Final.pptx
@@ -646,7 +646,7 @@
           <a:lstStyle/>
           <a:p>
             <a:r>
-              <a:t>About 45 seconds. “I prepared this recent demonstration to explore requirements from the role. The fictional case requests the procedural route and has records. The engine validates input, checks conditions and prerequisites, rejects conflicting selections, fills prepared paragraphs and returns a decision record.” For this case it selects jurisdiction, facts, procedural defense, records and relief. M5 needs both records and selected M3. Same inputs and rule version give the same output. The prototype is not the original research system. Describe implementation assistance and your own review/testing accurately when explaining who built each part. The legacy limitation_defense flag requests a procedural example; it does not establish a legal deadline violation.</a:t>
+              <a:t>About 45 seconds. “Cell 1 stores labelled source records: Act, section, text and any recorded judgment note. Cell 2 stores prepared paragraphs and the conditions for including them. The shared source ID connects the two.” For example, the records paragraph M5 requires available records AND selected procedural block M3; it links to C167. The output of these cells is a source table and a module-rule table, not an assembled document. There are ten educational source summaries and seven blocks in knowledge base 1.2.0. The date and version are manually assigned. Two simulated source updates exist for testing. The terms and exclusive routes are teaching examples, not verified legal instructions.</a:t>
             </a:r>
           </a:p>
         </p:txBody>
@@ -716,7 +716,7 @@
           <a:lstStyle/>
           <a:p>
             <a:r>
-              <a:t>About 45 seconds. “The review checks required citation markers and manually recorded judgment notes. A newer note flags selected modules linked to that source. It does not discover judgments online or assess legal applicability.” The four test groups check 25-run reproducibility, expected module order and citations on four fictional cases, rejection of configured conflicting routes, and warnings after an injected simulated judgment. Citation and retrieval assertions also run. All groups passed. This checks agreed software behaviour, not universal legal correctness. The source search uses TF-IDF with an uncalibrated 0.80 gate; exact-text examples demonstrate the mechanism, not paraphrase accuracy. There is no generative review model in this notebook.</a:t>
+              <a:t>About 50 seconds. “This is the main drafting step. The engine checks the case facts, evaluates paragraph conditions, checks prerequisites and rejects active configured conflicts. It fills the selected templates and returns both the draft and an explanation.” The sample output is M1 jurisdiction, M2 facts, M3 procedure, M5 records and M7 relief. M4 substantive and M6 bail are skipped because their flags default to False. M5 is included because has_records=True and M3 was included. The trace records expected/actual facts, missing prerequisites, decisions, version and fingerprints. The method returns the final document text, module IDs, required sources and trace. No LLM chooses paragraphs. The legacy limitation_defense flag is a supplied request for this procedural example, not an automated conclusion about a legal deadline.</a:t>
             </a:r>
           </a:p>
         </p:txBody>
@@ -786,7 +786,7 @@
           <a:lstStyle/>
           <a:p>
             <a:r>
-              <a:t>About 30–40 seconds. “With the team, I would start from one approved workflow, clarify its rules and exceptions, agree on examples, then build a small pilot and inspect the results with reviewers. I would learn the existing system before choosing new tools.” The demo uses summaries and fictional cases, not real lawyer-approved histories. It is not a production backend, SQL database or implemented appeals workflow. For a broader RAG discussion, LearnRAG is a separate demo with actual MiniLM/Qwen outputs and documented limits. Close with the question on the slide and listen. Ask about supervision, code review and legal approval if these have not been discussed. No percentage improvement is promised without a baseline.</a:t>
+              <a:t>About 60 seconds. “Cell 4 retrieves source summaries and performs structured checks on the draft. The controlled two-part search finds C54 and P420 after decomposition. In the sample draft, newer recorded notes flag M3-C54, M3-C167 and M5-C167: three module-source links. There are no missing-citation warnings in this unmodified draft. Searching the ordinary case summary accepts no source at the 0.80 gate; both split parts remain unresolved.” The threshold is uncalibrated, TF-IDF is word-based, decomposition uses separators, and no generative reviewer runs. Judgment warnings compare manually entered dates; they do not assess applicability. “Cell 5 checks 25-run reproducibility, four synthetic reference cases, rejection of conflicting routes and warning propagation after a simulated source update. All four groups pass; additional assertions exercise citation and retrieval paths.” Expected examples are synthetic, not actual lawyer-approved files. Close: “With the team I would start from one approved workflow and agreed examples. Which would be the most useful starting point?”</a:t>
             </a:r>
           </a:p>
         </p:txBody>
@@ -5382,7 +5382,7 @@
               </a:defRPr>
             </a:pPr>
             <a:r>
-              <a:t>PROJECT IMPLEMENTATION · A SEPARATE RECENT DEMO</a:t>
+              <a:t>IMPLEMENTATION · CELLS 1 + 2</a:t>
             </a:r>
           </a:p>
         </p:txBody>
@@ -5421,7 +5421,7 @@
               </a:defRPr>
             </a:pPr>
             <a:r>
-              <a:t>UkilRAG: facts in, a draft and explanation out</a:t>
+              <a:t>Store the sources. Define the paragraph rules.</a:t>
             </a:r>
           </a:p>
         </p:txBody>
@@ -5460,7 +5460,7 @@
               </a:defRPr>
             </a:pPr>
             <a:r>
-              <a:t>Prepared paragraphs follow explicit rules, not a language model’s choice.</a:t>
+              <a:t>10 sample legal sources and 7 reusable document blocks, connected by source IDs.</a:t>
             </a:r>
           </a:p>
         </p:txBody>
@@ -5542,7 +5542,7 @@
               </a:defRPr>
             </a:pPr>
             <a:r>
-              <a:t>Source: UkilRAG notebook. Fictional case and teaching rules, not verified legal guidance.</a:t>
+              <a:t>Cells 1–2: educational legal summaries and teaching rules; no complete official text or real judgment update.</a:t>
             </a:r>
           </a:p>
         </p:txBody>
@@ -5594,8 +5594,8 @@
         </p:nvSpPr>
         <p:spPr>
           <a:xfrm>
-            <a:off x="594360" y="2852928"/>
-            <a:ext cx="3172968" cy="2203704"/>
+            <a:off x="594360" y="2834640"/>
+            <a:ext cx="5193792" cy="2286000"/>
           </a:xfrm>
           <a:prstGeom prst="roundRect">
             <a:avLst>
@@ -5639,8 +5639,8 @@
         </p:nvSpPr>
         <p:spPr>
           <a:xfrm>
-            <a:off x="850392" y="3081528"/>
-            <a:ext cx="2660904" cy="329184"/>
+            <a:off x="850392" y="3063240"/>
+            <a:ext cx="4681727" cy="329184"/>
           </a:xfrm>
           <a:prstGeom prst="rect">
             <a:avLst/>
@@ -5665,7 +5665,7 @@
               </a:defRPr>
             </a:pPr>
             <a:r>
-              <a:t>CASE FACTS</a:t>
+              <a:t>CELL 1 · A SOURCE RECORD</a:t>
             </a:r>
           </a:p>
         </p:txBody>
@@ -5678,8 +5678,8 @@
         </p:nvSpPr>
         <p:spPr>
           <a:xfrm>
-            <a:off x="850392" y="3685032"/>
-            <a:ext cx="2660904" cy="1271016"/>
+            <a:off x="850392" y="3666744"/>
+            <a:ext cx="4681727" cy="1353312"/>
           </a:xfrm>
           <a:prstGeom prst="rect">
             <a:avLst/>
@@ -5704,7 +5704,7 @@
               </a:defRPr>
             </a:pPr>
             <a:r>
-              <a:t>Procedure: yes</a:t>
+              <a:t>ID: C167</a:t>
             </a:r>
           </a:p>
           <a:p>
@@ -5720,7 +5720,7 @@
               </a:defRPr>
             </a:pPr>
             <a:r>
-              <a:t>Records: yes</a:t>
+              <a:t>Section: 167</a:t>
             </a:r>
           </a:p>
           <a:p>
@@ -5736,7 +5736,7 @@
               </a:defRPr>
             </a:pPr>
             <a:r>
-              <a:t>Relief: yes</a:t>
+              <a:t>Act: Criminal Procedure, 1898</a:t>
             </a:r>
           </a:p>
         </p:txBody>
@@ -5749,8 +5749,8 @@
         </p:nvSpPr>
         <p:spPr>
           <a:xfrm>
-            <a:off x="4352544" y="2852928"/>
-            <a:ext cx="3172968" cy="2203704"/>
+            <a:off x="6391656" y="2834640"/>
+            <a:ext cx="5202936" cy="2286000"/>
           </a:xfrm>
           <a:prstGeom prst="roundRect">
             <a:avLst>
@@ -5758,7 +5758,7 @@
             </a:avLst>
           </a:prstGeom>
           <a:solidFill>
-            <a:srgbClr val="F1F5F7"/>
+            <a:srgbClr val="E8F3F0"/>
           </a:solidFill>
           <a:ln>
             <a:noFill/>
@@ -5794,8 +5794,8 @@
         </p:nvSpPr>
         <p:spPr>
           <a:xfrm>
-            <a:off x="4608576" y="3081528"/>
-            <a:ext cx="2660904" cy="329184"/>
+            <a:off x="6647688" y="3063240"/>
+            <a:ext cx="4690872" cy="329184"/>
           </a:xfrm>
           <a:prstGeom prst="rect">
             <a:avLst/>
@@ -5820,7 +5820,7 @@
               </a:defRPr>
             </a:pPr>
             <a:r>
-              <a:t>RULE CHECKS</a:t>
+              <a:t>CELL 2 · A PARAGRAPH RULE</a:t>
             </a:r>
           </a:p>
         </p:txBody>
@@ -5833,8 +5833,8 @@
         </p:nvSpPr>
         <p:spPr>
           <a:xfrm>
-            <a:off x="4608576" y="3685032"/>
-            <a:ext cx="2660904" cy="1271016"/>
+            <a:off x="6647688" y="3666744"/>
+            <a:ext cx="4690872" cy="1335024"/>
           </a:xfrm>
           <a:prstGeom prst="rect">
             <a:avLst/>
@@ -5851,7 +5851,7 @@
               <a:spcAft>
                 <a:spcPts val="1000"/>
               </a:spcAft>
-              <a:defRPr sz="2000" b="1">
+              <a:defRPr sz="1700" b="1">
                 <a:solidFill>
                   <a:srgbClr val="172F46"/>
                 </a:solidFill>
@@ -5859,7 +5859,7 @@
               </a:defRPr>
             </a:pPr>
             <a:r>
-              <a:t>Facts match?</a:t>
+              <a:t>Records available + M3 selected</a:t>
             </a:r>
           </a:p>
           <a:p>
@@ -5867,7 +5867,7 @@
               <a:spcAft>
                 <a:spcPts val="1000"/>
               </a:spcAft>
-              <a:defRPr sz="2000" b="1">
+              <a:defRPr sz="1700" b="1">
                 <a:solidFill>
                   <a:srgbClr val="172F46"/>
                 </a:solidFill>
@@ -5875,7 +5875,7 @@
               </a:defRPr>
             </a:pPr>
             <a:r>
-              <a:t>Blocks ready?</a:t>
+              <a:t>→ include the records paragraph</a:t>
             </a:r>
           </a:p>
           <a:p>
@@ -5883,7 +5883,7 @@
               <a:spcAft>
                 <a:spcPts val="1000"/>
               </a:spcAft>
-              <a:defRPr sz="2000" b="1">
+              <a:defRPr sz="1700" b="1">
                 <a:solidFill>
                   <a:srgbClr val="172F46"/>
                 </a:solidFill>
@@ -5891,29 +5891,27 @@
               </a:defRPr>
             </a:pPr>
             <a:r>
-              <a:t>Any conflicts?</a:t>
-            </a:r>
-          </a:p>
-        </p:txBody>
-      </p:sp>
-      <p:sp>
-        <p:nvSpPr>
-          <p:cNvPr id="15" name="Rounded Rectangle 14"/>
+              <a:t>→ cite C167</a:t>
+            </a:r>
+          </a:p>
+        </p:txBody>
+      </p:sp>
+      <p:sp>
+        <p:nvSpPr>
+          <p:cNvPr id="15" name="Rectangle 14"/>
           <p:cNvSpPr/>
           <p:nvPr/>
         </p:nvSpPr>
         <p:spPr>
           <a:xfrm>
-            <a:off x="8110727" y="2852928"/>
-            <a:ext cx="3483864" cy="2203704"/>
-          </a:xfrm>
-          <a:prstGeom prst="roundRect">
-            <a:avLst>
-              <a:gd name="adj" fmla="val 8000"/>
-            </a:avLst>
+            <a:off x="594360" y="5559552"/>
+            <a:ext cx="11000232" cy="594360"/>
+          </a:xfrm>
+          <a:prstGeom prst="rect">
+            <a:avLst/>
           </a:prstGeom>
           <a:solidFill>
-            <a:srgbClr val="E8F3F0"/>
+            <a:srgbClr val="172F46"/>
           </a:solidFill>
           <a:ln>
             <a:noFill/>
@@ -5949,237 +5947,6 @@
         </p:nvSpPr>
         <p:spPr>
           <a:xfrm>
-            <a:off x="8366759" y="3081528"/>
-            <a:ext cx="2971800" cy="329184"/>
-          </a:xfrm>
-          <a:prstGeom prst="rect">
-            <a:avLst/>
-          </a:prstGeom>
-          <a:noFill/>
-        </p:spPr>
-        <p:txBody>
-          <a:bodyPr wrap="square" tIns="0" bIns="0" lIns="0" rIns="0">
-            <a:spAutoFit/>
-          </a:bodyPr>
-          <a:lstStyle/>
-          <a:p>
-            <a:pPr>
-              <a:spcAft>
-                <a:spcPts val="1000"/>
-              </a:spcAft>
-              <a:defRPr sz="1200" b="1">
-                <a:solidFill>
-                  <a:srgbClr val="117970"/>
-                </a:solidFill>
-                <a:latin typeface="DejaVu Sans"/>
-              </a:defRPr>
-            </a:pPr>
-            <a:r>
-              <a:t>RESULT</a:t>
-            </a:r>
-          </a:p>
-        </p:txBody>
-      </p:sp>
-      <p:sp>
-        <p:nvSpPr>
-          <p:cNvPr id="17" name="TextBox 16"/>
-          <p:cNvSpPr txBox="1"/>
-          <p:nvPr/>
-        </p:nvSpPr>
-        <p:spPr>
-          <a:xfrm>
-            <a:off x="8366759" y="3685032"/>
-            <a:ext cx="2971800" cy="1271016"/>
-          </a:xfrm>
-          <a:prstGeom prst="rect">
-            <a:avLst/>
-          </a:prstGeom>
-          <a:noFill/>
-        </p:spPr>
-        <p:txBody>
-          <a:bodyPr wrap="square" tIns="0" bIns="0" lIns="0" rIns="0">
-            <a:spAutoFit/>
-          </a:bodyPr>
-          <a:lstStyle/>
-          <a:p>
-            <a:pPr>
-              <a:spcAft>
-                <a:spcPts val="1000"/>
-              </a:spcAft>
-              <a:defRPr sz="2000" b="1">
-                <a:solidFill>
-                  <a:srgbClr val="172F46"/>
-                </a:solidFill>
-                <a:latin typeface="DejaVu Sans"/>
-              </a:defRPr>
-            </a:pPr>
-            <a:r>
-              <a:t>Chosen paragraphs</a:t>
-            </a:r>
-          </a:p>
-          <a:p>
-            <a:pPr>
-              <a:spcAft>
-                <a:spcPts val="1000"/>
-              </a:spcAft>
-              <a:defRPr sz="2000" b="1">
-                <a:solidFill>
-                  <a:srgbClr val="172F46"/>
-                </a:solidFill>
-                <a:latin typeface="DejaVu Sans"/>
-              </a:defRPr>
-            </a:pPr>
-            <a:r>
-              <a:t>Fixed order</a:t>
-            </a:r>
-          </a:p>
-          <a:p>
-            <a:pPr>
-              <a:spcAft>
-                <a:spcPts val="1000"/>
-              </a:spcAft>
-              <a:defRPr sz="2000" b="1">
-                <a:solidFill>
-                  <a:srgbClr val="172F46"/>
-                </a:solidFill>
-                <a:latin typeface="DejaVu Sans"/>
-              </a:defRPr>
-            </a:pPr>
-            <a:r>
-              <a:t>Decision record</a:t>
-            </a:r>
-          </a:p>
-        </p:txBody>
-      </p:sp>
-      <p:sp>
-        <p:nvSpPr>
-          <p:cNvPr id="18" name="TextBox 17"/>
-          <p:cNvSpPr txBox="1"/>
-          <p:nvPr/>
-        </p:nvSpPr>
-        <p:spPr>
-          <a:xfrm>
-            <a:off x="3904487" y="3749039"/>
-            <a:ext cx="274320" cy="365760"/>
-          </a:xfrm>
-          <a:prstGeom prst="rect">
-            <a:avLst/>
-          </a:prstGeom>
-          <a:noFill/>
-        </p:spPr>
-        <p:txBody>
-          <a:bodyPr wrap="square" tIns="0" bIns="0" lIns="0" rIns="0">
-            <a:spAutoFit/>
-          </a:bodyPr>
-          <a:lstStyle/>
-          <a:p>
-            <a:pPr>
-              <a:spcAft>
-                <a:spcPts val="1000"/>
-              </a:spcAft>
-              <a:defRPr sz="2400" b="1">
-                <a:solidFill>
-                  <a:srgbClr val="117970"/>
-                </a:solidFill>
-                <a:latin typeface="DejaVu Sans"/>
-              </a:defRPr>
-            </a:pPr>
-            <a:r>
-              <a:t>→</a:t>
-            </a:r>
-          </a:p>
-        </p:txBody>
-      </p:sp>
-      <p:sp>
-        <p:nvSpPr>
-          <p:cNvPr id="19" name="TextBox 18"/>
-          <p:cNvSpPr txBox="1"/>
-          <p:nvPr/>
-        </p:nvSpPr>
-        <p:spPr>
-          <a:xfrm>
-            <a:off x="7671816" y="3749039"/>
-            <a:ext cx="274320" cy="365760"/>
-          </a:xfrm>
-          <a:prstGeom prst="rect">
-            <a:avLst/>
-          </a:prstGeom>
-          <a:noFill/>
-        </p:spPr>
-        <p:txBody>
-          <a:bodyPr wrap="square" tIns="0" bIns="0" lIns="0" rIns="0">
-            <a:spAutoFit/>
-          </a:bodyPr>
-          <a:lstStyle/>
-          <a:p>
-            <a:pPr>
-              <a:spcAft>
-                <a:spcPts val="1000"/>
-              </a:spcAft>
-              <a:defRPr sz="2400" b="1">
-                <a:solidFill>
-                  <a:srgbClr val="117970"/>
-                </a:solidFill>
-                <a:latin typeface="DejaVu Sans"/>
-              </a:defRPr>
-            </a:pPr>
-            <a:r>
-              <a:t>→</a:t>
-            </a:r>
-          </a:p>
-        </p:txBody>
-      </p:sp>
-      <p:sp>
-        <p:nvSpPr>
-          <p:cNvPr id="20" name="Rectangle 19"/>
-          <p:cNvSpPr/>
-          <p:nvPr/>
-        </p:nvSpPr>
-        <p:spPr>
-          <a:xfrm>
-            <a:off x="594360" y="5559552"/>
-            <a:ext cx="11000232" cy="594360"/>
-          </a:xfrm>
-          <a:prstGeom prst="rect">
-            <a:avLst/>
-          </a:prstGeom>
-          <a:solidFill>
-            <a:srgbClr val="172F46"/>
-          </a:solidFill>
-          <a:ln>
-            <a:noFill/>
-          </a:ln>
-        </p:spPr>
-        <p:style>
-          <a:lnRef idx="1">
-            <a:schemeClr val="accent1"/>
-          </a:lnRef>
-          <a:fillRef idx="3">
-            <a:schemeClr val="accent1"/>
-          </a:fillRef>
-          <a:effectRef idx="0">
-            <a:schemeClr val="accent1"/>
-          </a:effectRef>
-          <a:fontRef idx="minor">
-            <a:schemeClr val="lt1"/>
-          </a:fontRef>
-        </p:style>
-        <p:txBody>
-          <a:bodyPr rtlCol="0" anchor="ctr"/>
-          <a:lstStyle/>
-          <a:p>
-            <a:pPr algn="ctr"/>
-          </a:p>
-        </p:txBody>
-      </p:sp>
-      <p:sp>
-        <p:nvSpPr>
-          <p:cNvPr id="21" name="TextBox 20"/>
-          <p:cNvSpPr txBox="1"/>
-          <p:nvPr/>
-        </p:nvSpPr>
-        <p:spPr>
-          <a:xfrm>
             <a:off x="850392" y="5742432"/>
             <a:ext cx="10469880" cy="292608"/>
           </a:xfrm>
@@ -6206,7 +5973,7 @@
               </a:defRPr>
             </a:pPr>
             <a:r>
-              <a:t>Records paragraph: include only when records exist and the procedural block is selected.</a:t>
+              <a:t>The source ID links a paragraph to the legal information used in its review.</a:t>
             </a:r>
           </a:p>
         </p:txBody>
@@ -6314,7 +6081,7 @@
               </a:defRPr>
             </a:pPr>
             <a:r>
-              <a:t>PROJECT IMPLEMENTATION · REVIEW AND TESTS</a:t>
+              <a:t>IMPLEMENTATION · CELL 3</a:t>
             </a:r>
           </a:p>
         </p:txBody>
@@ -6353,7 +6120,7 @@
               </a:defRPr>
             </a:pPr>
             <a:r>
-              <a:t>Check the references. Check the behaviour.</a:t>
+              <a:t>Apply the rules and explain the selection</a:t>
             </a:r>
           </a:p>
         </p:txBody>
@@ -6392,7 +6159,7 @@
               </a:defRPr>
             </a:pPr>
             <a:r>
-              <a:t>Keep the draft explainable when source records or rules change.</a:t>
+              <a:t>Same facts and rule version → the same prepared draft.</a:t>
             </a:r>
           </a:p>
         </p:txBody>
@@ -6474,7 +6241,7 @@
               </a:defRPr>
             </a:pPr>
             <a:r>
-              <a:t>Evidence: executed UkilRAG notebook. Four test groups passed on synthetic cases; no legal-accuracy claim.</a:t>
+              <a:t>Cell 3: actual selected sequence from fictional SAMPLE_CASE. Prepared templates, not generated legal arguments.</a:t>
             </a:r>
           </a:p>
         </p:txBody>
@@ -6526,8 +6293,8 @@
         </p:nvSpPr>
         <p:spPr>
           <a:xfrm>
-            <a:off x="594360" y="2834640"/>
-            <a:ext cx="5193792" cy="2286000"/>
+            <a:off x="594360" y="2743200"/>
+            <a:ext cx="3529584" cy="2487168"/>
           </a:xfrm>
           <a:prstGeom prst="roundRect">
             <a:avLst>
@@ -6571,8 +6338,8 @@
         </p:nvSpPr>
         <p:spPr>
           <a:xfrm>
-            <a:off x="850392" y="3063240"/>
-            <a:ext cx="4681727" cy="329184"/>
+            <a:off x="850392" y="2971800"/>
+            <a:ext cx="3017520" cy="329184"/>
           </a:xfrm>
           <a:prstGeom prst="rect">
             <a:avLst/>
@@ -6597,7 +6364,7 @@
               </a:defRPr>
             </a:pPr>
             <a:r>
-              <a:t>REVIEW CHECKS</a:t>
+              <a:t>INPUT FACTS</a:t>
             </a:r>
           </a:p>
         </p:txBody>
@@ -6610,8 +6377,8 @@
         </p:nvSpPr>
         <p:spPr>
           <a:xfrm>
-            <a:off x="850392" y="3666744"/>
-            <a:ext cx="4681727" cy="1353312"/>
+            <a:off x="850392" y="3575304"/>
+            <a:ext cx="3017520" cy="1554480"/>
           </a:xfrm>
           <a:prstGeom prst="rect">
             <a:avLst/>
@@ -6636,7 +6403,7 @@
               </a:defRPr>
             </a:pPr>
             <a:r>
-              <a:t>Missing citation markers</a:t>
+              <a:t>Procedure: yes</a:t>
             </a:r>
           </a:p>
           <a:p>
@@ -6652,7 +6419,7 @@
               </a:defRPr>
             </a:pPr>
             <a:r>
-              <a:t>Unknown or unlinked references</a:t>
+              <a:t>Records: yes</a:t>
             </a:r>
           </a:p>
           <a:p>
@@ -6668,21 +6435,60 @@
               </a:defRPr>
             </a:pPr>
             <a:r>
-              <a:t>Newer recorded judgment notes</a:t>
-            </a:r>
-          </a:p>
-        </p:txBody>
-      </p:sp>
-      <p:sp>
-        <p:nvSpPr>
-          <p:cNvPr id="12" name="Rounded Rectangle 11"/>
+              <a:t>Relief: yes</a:t>
+            </a:r>
+          </a:p>
+        </p:txBody>
+      </p:sp>
+      <p:sp>
+        <p:nvSpPr>
+          <p:cNvPr id="12" name="TextBox 11"/>
+          <p:cNvSpPr txBox="1"/>
+          <p:nvPr/>
+        </p:nvSpPr>
+        <p:spPr>
+          <a:xfrm>
+            <a:off x="4215384" y="3767328"/>
+            <a:ext cx="320040" cy="411480"/>
+          </a:xfrm>
+          <a:prstGeom prst="rect">
+            <a:avLst/>
+          </a:prstGeom>
+          <a:noFill/>
+        </p:spPr>
+        <p:txBody>
+          <a:bodyPr wrap="square" tIns="0" bIns="0" lIns="0" rIns="0">
+            <a:spAutoFit/>
+          </a:bodyPr>
+          <a:lstStyle/>
+          <a:p>
+            <a:pPr>
+              <a:spcAft>
+                <a:spcPts val="1000"/>
+              </a:spcAft>
+              <a:defRPr sz="2400" b="1">
+                <a:solidFill>
+                  <a:srgbClr val="117970"/>
+                </a:solidFill>
+                <a:latin typeface="DejaVu Sans"/>
+              </a:defRPr>
+            </a:pPr>
+            <a:r>
+              <a:t>→</a:t>
+            </a:r>
+          </a:p>
+        </p:txBody>
+      </p:sp>
+      <p:sp>
+        <p:nvSpPr>
+          <p:cNvPr id="13" name="Rounded Rectangle 12"/>
           <p:cNvSpPr/>
           <p:nvPr/>
         </p:nvSpPr>
         <p:spPr>
           <a:xfrm>
-            <a:off x="6391656" y="2834640"/>
-            <a:ext cx="5202936" cy="2286000"/>
+            <a:off x="4663440" y="2743200"/>
+            <a:ext cx="6931152" cy="2487168"/>
           </a:xfrm>
           <a:prstGeom prst="roundRect">
             <a:avLst>
@@ -6720,14 +6526,14 @@
       </p:sp>
       <p:sp>
         <p:nvSpPr>
-          <p:cNvPr id="13" name="TextBox 12"/>
+          <p:cNvPr id="14" name="TextBox 13"/>
           <p:cNvSpPr txBox="1"/>
           <p:nvPr/>
         </p:nvSpPr>
         <p:spPr>
           <a:xfrm>
-            <a:off x="6647688" y="3063240"/>
-            <a:ext cx="4690872" cy="329184"/>
+            <a:off x="4919472" y="2971800"/>
+            <a:ext cx="6419088" cy="329184"/>
           </a:xfrm>
           <a:prstGeom prst="rect">
             <a:avLst/>
@@ -6752,21 +6558,21 @@
               </a:defRPr>
             </a:pPr>
             <a:r>
-              <a:t>FOUR TEST GROUPS</a:t>
-            </a:r>
-          </a:p>
-        </p:txBody>
-      </p:sp>
-      <p:sp>
-        <p:nvSpPr>
-          <p:cNvPr id="14" name="TextBox 13"/>
+              <a:t>BASIC OUTPUT · SELECTED PARAGRAPHS</a:t>
+            </a:r>
+          </a:p>
+        </p:txBody>
+      </p:sp>
+      <p:sp>
+        <p:nvSpPr>
+          <p:cNvPr id="15" name="TextBox 14"/>
           <p:cNvSpPr txBox="1"/>
           <p:nvPr/>
         </p:nvSpPr>
         <p:spPr>
           <a:xfrm>
-            <a:off x="6647688" y="3666744"/>
-            <a:ext cx="4690872" cy="1353312"/>
+            <a:off x="4919472" y="3575304"/>
+            <a:ext cx="6419088" cy="795528"/>
           </a:xfrm>
           <a:prstGeom prst="rect">
             <a:avLst/>
@@ -6783,7 +6589,7 @@
               <a:spcAft>
                 <a:spcPts val="1000"/>
               </a:spcAft>
-              <a:defRPr sz="2000" b="1">
+              <a:defRPr sz="1900" b="1">
                 <a:solidFill>
                   <a:srgbClr val="172F46"/>
                 </a:solidFill>
@@ -6791,7 +6597,7 @@
               </a:defRPr>
             </a:pPr>
             <a:r>
-              <a:t>Repeatability: 25 runs</a:t>
+              <a:t>Jurisdiction → Facts → Procedure</a:t>
             </a:r>
           </a:p>
           <a:p>
@@ -6799,7 +6605,7 @@
               <a:spcAft>
                 <a:spcPts val="1000"/>
               </a:spcAft>
-              <a:defRPr sz="2000" b="1">
+              <a:defRPr sz="1900" b="1">
                 <a:solidFill>
                   <a:srgbClr val="172F46"/>
                 </a:solidFill>
@@ -6807,30 +6613,53 @@
               </a:defRPr>
             </a:pPr>
             <a:r>
-              <a:t>Expected results: 4 cases</a:t>
-            </a:r>
-          </a:p>
+              <a:t>→ Records → Relief</a:t>
+            </a:r>
+          </a:p>
+        </p:txBody>
+      </p:sp>
+      <p:sp>
+        <p:nvSpPr>
+          <p:cNvPr id="16" name="TextBox 15"/>
+          <p:cNvSpPr txBox="1"/>
+          <p:nvPr/>
+        </p:nvSpPr>
+        <p:spPr>
+          <a:xfrm>
+            <a:off x="4919472" y="4581144"/>
+            <a:ext cx="6419088" cy="512064"/>
+          </a:xfrm>
+          <a:prstGeom prst="rect">
+            <a:avLst/>
+          </a:prstGeom>
+          <a:noFill/>
+        </p:spPr>
+        <p:txBody>
+          <a:bodyPr wrap="square" tIns="0" bIns="0" lIns="0" rIns="0">
+            <a:spAutoFit/>
+          </a:bodyPr>
+          <a:lstStyle/>
           <a:p>
             <a:pPr>
               <a:spcAft>
                 <a:spcPts val="1000"/>
               </a:spcAft>
-              <a:defRPr sz="2000" b="1">
-                <a:solidFill>
-                  <a:srgbClr val="172F46"/>
+              <a:defRPr sz="1300" b="0">
+                <a:solidFill>
+                  <a:srgbClr val="263B4B"/>
                 </a:solidFill>
                 <a:latin typeface="DejaVu Sans"/>
               </a:defRPr>
             </a:pPr>
             <a:r>
-              <a:t>Conflicts and update warnings</a:t>
-            </a:r>
-          </a:p>
-        </p:txBody>
-      </p:sp>
-      <p:sp>
-        <p:nvSpPr>
-          <p:cNvPr id="15" name="Rectangle 14"/>
+              <a:t>Decision record: M5 INCLUDED — records are available and M3 is selected.</a:t>
+            </a:r>
+          </a:p>
+        </p:txBody>
+      </p:sp>
+      <p:sp>
+        <p:nvSpPr>
+          <p:cNvPr id="17" name="Rectangle 16"/>
           <p:cNvSpPr/>
           <p:nvPr/>
         </p:nvSpPr>
@@ -6873,7 +6702,7 @@
       </p:sp>
       <p:sp>
         <p:nvSpPr>
-          <p:cNvPr id="16" name="TextBox 15"/>
+          <p:cNvPr id="18" name="TextBox 17"/>
           <p:cNvSpPr txBox="1"/>
           <p:nvPr/>
         </p:nvSpPr>
@@ -6905,7 +6734,7 @@
               </a:defRPr>
             </a:pPr>
             <a:r>
-              <a:t>An update warning means “review this paragraph”—not “rewrite it automatically.”</a:t>
+              <a:t>Other blocks are skipped when their conditions fail; conflicting choices stop assembly.</a:t>
             </a:r>
           </a:p>
         </p:txBody>
@@ -7013,7 +6842,7 @@
               </a:defRPr>
             </a:pPr>
             <a:r>
-              <a:t>HOW I WOULD CONTRIBUTE</a:t>
+              <a:t>IMPLEMENTATION · CELLS 4 + 5</a:t>
             </a:r>
           </a:p>
         </p:txBody>
@@ -7052,7 +6881,7 @@
               </a:defRPr>
             </a:pPr>
             <a:r>
-              <a:t>Start with one approved workflow</a:t>
+              <a:t>Review the draft. Test the behaviour.</a:t>
             </a:r>
           </a:p>
         </p:txBody>
@@ -7091,7 +6920,7 @@
               </a:defRPr>
             </a:pPr>
             <a:r>
-              <a:t>A small, reviewable pilot before wider automation.</a:t>
+              <a:t>Check references and recorded updates, then rerun known examples after changes.</a:t>
             </a:r>
           </a:p>
         </p:txBody>
@@ -7173,7 +7002,7 @@
               </a:defRPr>
             </a:pPr>
             <a:r>
-              <a:t>Proposed starting approach from the internship brief. Demos use sample summaries and fictional legal cases.</a:t>
+              <a:t>Cells 4–5: saved notebook outputs. Judgment notes and reference cases are synthetic; warnings need human assessment.</a:t>
             </a:r>
           </a:p>
         </p:txBody>
@@ -7225,8 +7054,8 @@
         </p:nvSpPr>
         <p:spPr>
           <a:xfrm>
-            <a:off x="594360" y="2852928"/>
-            <a:ext cx="3493008" cy="2203704"/>
+            <a:off x="594360" y="2834640"/>
+            <a:ext cx="5193792" cy="2286000"/>
           </a:xfrm>
           <a:prstGeom prst="roundRect">
             <a:avLst>
@@ -7270,8 +7099,8 @@
         </p:nvSpPr>
         <p:spPr>
           <a:xfrm>
-            <a:off x="850392" y="3081528"/>
-            <a:ext cx="2980944" cy="329184"/>
+            <a:off x="850392" y="3063240"/>
+            <a:ext cx="4681728" cy="329184"/>
           </a:xfrm>
           <a:prstGeom prst="rect">
             <a:avLst/>
@@ -7296,7 +7125,7 @@
               </a:defRPr>
             </a:pPr>
             <a:r>
-              <a:t>DISCOVER</a:t>
+              <a:t>CELL 4 · EXAMPLE REVIEW OUTPUT</a:t>
             </a:r>
           </a:p>
         </p:txBody>
@@ -7309,8 +7138,8 @@
         </p:nvSpPr>
         <p:spPr>
           <a:xfrm>
-            <a:off x="850392" y="3685032"/>
-            <a:ext cx="2980944" cy="1271016"/>
+            <a:off x="850392" y="3666744"/>
+            <a:ext cx="4681728" cy="1335024"/>
           </a:xfrm>
           <a:prstGeom prst="rect">
             <a:avLst/>
@@ -7327,7 +7156,7 @@
               <a:spcAft>
                 <a:spcPts val="1000"/>
               </a:spcAft>
-              <a:defRPr sz="2000" b="1">
+              <a:defRPr sz="1700" b="1">
                 <a:solidFill>
                   <a:srgbClr val="172F46"/>
                 </a:solidFill>
@@ -7335,7 +7164,7 @@
               </a:defRPr>
             </a:pPr>
             <a:r>
-              <a:t>Work through an</a:t>
+              <a:t>Search demo: C54 + P420 found</a:t>
             </a:r>
           </a:p>
           <a:p>
@@ -7343,7 +7172,7 @@
               <a:spcAft>
                 <a:spcPts val="1000"/>
               </a:spcAft>
-              <a:defRPr sz="2000" b="1">
+              <a:defRPr sz="1700" b="1">
                 <a:solidFill>
                   <a:srgbClr val="172F46"/>
                 </a:solidFill>
@@ -7351,7 +7180,23 @@
               </a:defRPr>
             </a:pPr>
             <a:r>
-              <a:t>approved example.</a:t>
+              <a:t>Draft review: 3 update warnings</a:t>
+            </a:r>
+          </a:p>
+          <a:p>
+            <a:pPr>
+              <a:spcAft>
+                <a:spcPts val="1000"/>
+              </a:spcAft>
+              <a:defRPr sz="1700" b="1">
+                <a:solidFill>
+                  <a:srgbClr val="172F46"/>
+                </a:solidFill>
+                <a:latin typeface="DejaVu Sans"/>
+              </a:defRPr>
+            </a:pPr>
+            <a:r>
+              <a:t>Case summary: no accepted sources</a:t>
             </a:r>
           </a:p>
         </p:txBody>
@@ -7364,8 +7209,8 @@
         </p:nvSpPr>
         <p:spPr>
           <a:xfrm>
-            <a:off x="4343400" y="2852928"/>
-            <a:ext cx="3493008" cy="2203704"/>
+            <a:off x="6391656" y="2834640"/>
+            <a:ext cx="5202936" cy="2286000"/>
           </a:xfrm>
           <a:prstGeom prst="roundRect">
             <a:avLst>
@@ -7373,7 +7218,7 @@
             </a:avLst>
           </a:prstGeom>
           <a:solidFill>
-            <a:srgbClr val="F1F5F7"/>
+            <a:srgbClr val="E8F3F0"/>
           </a:solidFill>
           <a:ln>
             <a:noFill/>
@@ -7409,8 +7254,8 @@
         </p:nvSpPr>
         <p:spPr>
           <a:xfrm>
-            <a:off x="4599432" y="3081528"/>
-            <a:ext cx="2980944" cy="329184"/>
+            <a:off x="6647688" y="3063240"/>
+            <a:ext cx="4690872" cy="329184"/>
           </a:xfrm>
           <a:prstGeom prst="rect">
             <a:avLst/>
@@ -7435,7 +7280,7 @@
               </a:defRPr>
             </a:pPr>
             <a:r>
-              <a:t>BUILD</a:t>
+              <a:t>CELL 5 · FOUR TEST GROUPS PASS</a:t>
             </a:r>
           </a:p>
         </p:txBody>
@@ -7448,8 +7293,8 @@
         </p:nvSpPr>
         <p:spPr>
           <a:xfrm>
-            <a:off x="4599432" y="3685032"/>
-            <a:ext cx="2980944" cy="1271016"/>
+            <a:off x="6647688" y="3666744"/>
+            <a:ext cx="4690872" cy="1335024"/>
           </a:xfrm>
           <a:prstGeom prst="rect">
             <a:avLst/>
@@ -7466,7 +7311,7 @@
               <a:spcAft>
                 <a:spcPts val="1000"/>
               </a:spcAft>
-              <a:defRPr sz="2000" b="1">
+              <a:defRPr sz="1700" b="1">
                 <a:solidFill>
                   <a:srgbClr val="172F46"/>
                 </a:solidFill>
@@ -7474,7 +7319,7 @@
               </a:defRPr>
             </a:pPr>
             <a:r>
-              <a:t>Agree on rules and</a:t>
+              <a:t>25 runs give matching results</a:t>
             </a:r>
           </a:p>
           <a:p>
@@ -7482,7 +7327,7 @@
               <a:spcAft>
                 <a:spcPts val="1000"/>
               </a:spcAft>
-              <a:defRPr sz="2000" b="1">
+              <a:defRPr sz="1700" b="1">
                 <a:solidFill>
                   <a:srgbClr val="172F46"/>
                 </a:solidFill>
@@ -7490,29 +7335,43 @@
               </a:defRPr>
             </a:pPr>
             <a:r>
-              <a:t>expected results.</a:t>
-            </a:r>
-          </a:p>
-        </p:txBody>
-      </p:sp>
-      <p:sp>
-        <p:nvSpPr>
-          <p:cNvPr id="15" name="Rounded Rectangle 14"/>
+              <a:t>4 cases match their expectations</a:t>
+            </a:r>
+          </a:p>
+          <a:p>
+            <a:pPr>
+              <a:spcAft>
+                <a:spcPts val="1000"/>
+              </a:spcAft>
+              <a:defRPr sz="1700" b="1">
+                <a:solidFill>
+                  <a:srgbClr val="172F46"/>
+                </a:solidFill>
+                <a:latin typeface="DejaVu Sans"/>
+              </a:defRPr>
+            </a:pPr>
+            <a:r>
+              <a:t>Conflicts rejected; updates flagged</a:t>
+            </a:r>
+          </a:p>
+        </p:txBody>
+      </p:sp>
+      <p:sp>
+        <p:nvSpPr>
+          <p:cNvPr id="15" name="Rectangle 14"/>
           <p:cNvSpPr/>
           <p:nvPr/>
         </p:nvSpPr>
         <p:spPr>
           <a:xfrm>
-            <a:off x="8092440" y="2852928"/>
-            <a:ext cx="3493008" cy="2203704"/>
-          </a:xfrm>
-          <a:prstGeom prst="roundRect">
-            <a:avLst>
-              <a:gd name="adj" fmla="val 8000"/>
-            </a:avLst>
+            <a:off x="594360" y="5559552"/>
+            <a:ext cx="11000232" cy="594360"/>
+          </a:xfrm>
+          <a:prstGeom prst="rect">
+            <a:avLst/>
           </a:prstGeom>
           <a:solidFill>
-            <a:srgbClr val="F1F5F7"/>
+            <a:srgbClr val="172F46"/>
           </a:solidFill>
           <a:ln>
             <a:noFill/>
@@ -7548,159 +7407,6 @@
         </p:nvSpPr>
         <p:spPr>
           <a:xfrm>
-            <a:off x="8348471" y="3081528"/>
-            <a:ext cx="2980944" cy="329184"/>
-          </a:xfrm>
-          <a:prstGeom prst="rect">
-            <a:avLst/>
-          </a:prstGeom>
-          <a:noFill/>
-        </p:spPr>
-        <p:txBody>
-          <a:bodyPr wrap="square" tIns="0" bIns="0" lIns="0" rIns="0">
-            <a:spAutoFit/>
-          </a:bodyPr>
-          <a:lstStyle/>
-          <a:p>
-            <a:pPr>
-              <a:spcAft>
-                <a:spcPts val="1000"/>
-              </a:spcAft>
-              <a:defRPr sz="1200" b="1">
-                <a:solidFill>
-                  <a:srgbClr val="117970"/>
-                </a:solidFill>
-                <a:latin typeface="DejaVu Sans"/>
-              </a:defRPr>
-            </a:pPr>
-            <a:r>
-              <a:t>REVIEW</a:t>
-            </a:r>
-          </a:p>
-        </p:txBody>
-      </p:sp>
-      <p:sp>
-        <p:nvSpPr>
-          <p:cNvPr id="17" name="TextBox 16"/>
-          <p:cNvSpPr txBox="1"/>
-          <p:nvPr/>
-        </p:nvSpPr>
-        <p:spPr>
-          <a:xfrm>
-            <a:off x="8348471" y="3685032"/>
-            <a:ext cx="2980944" cy="1271016"/>
-          </a:xfrm>
-          <a:prstGeom prst="rect">
-            <a:avLst/>
-          </a:prstGeom>
-          <a:noFill/>
-        </p:spPr>
-        <p:txBody>
-          <a:bodyPr wrap="square" tIns="0" bIns="0" lIns="0" rIns="0">
-            <a:spAutoFit/>
-          </a:bodyPr>
-          <a:lstStyle/>
-          <a:p>
-            <a:pPr>
-              <a:spcAft>
-                <a:spcPts val="1000"/>
-              </a:spcAft>
-              <a:defRPr sz="2000" b="1">
-                <a:solidFill>
-                  <a:srgbClr val="172F46"/>
-                </a:solidFill>
-                <a:latin typeface="DejaVu Sans"/>
-              </a:defRPr>
-            </a:pPr>
-            <a:r>
-              <a:t>Test with the team.</a:t>
-            </a:r>
-          </a:p>
-          <a:p>
-            <a:pPr>
-              <a:spcAft>
-                <a:spcPts val="1000"/>
-              </a:spcAft>
-              <a:defRPr sz="2000" b="1">
-                <a:solidFill>
-                  <a:srgbClr val="172F46"/>
-                </a:solidFill>
-                <a:latin typeface="DejaVu Sans"/>
-              </a:defRPr>
-            </a:pPr>
-            <a:r>
-              <a:t>Review differences.</a:t>
-            </a:r>
-          </a:p>
-          <a:p>
-            <a:pPr>
-              <a:spcAft>
-                <a:spcPts val="1000"/>
-              </a:spcAft>
-              <a:defRPr sz="2000" b="1">
-                <a:solidFill>
-                  <a:srgbClr val="172F46"/>
-                </a:solidFill>
-                <a:latin typeface="DejaVu Sans"/>
-              </a:defRPr>
-            </a:pPr>
-            <a:r>
-              <a:t>Improve together.</a:t>
-            </a:r>
-          </a:p>
-        </p:txBody>
-      </p:sp>
-      <p:sp>
-        <p:nvSpPr>
-          <p:cNvPr id="18" name="Rectangle 17"/>
-          <p:cNvSpPr/>
-          <p:nvPr/>
-        </p:nvSpPr>
-        <p:spPr>
-          <a:xfrm>
-            <a:off x="594360" y="5559552"/>
-            <a:ext cx="11000232" cy="594360"/>
-          </a:xfrm>
-          <a:prstGeom prst="rect">
-            <a:avLst/>
-          </a:prstGeom>
-          <a:solidFill>
-            <a:srgbClr val="172F46"/>
-          </a:solidFill>
-          <a:ln>
-            <a:noFill/>
-          </a:ln>
-        </p:spPr>
-        <p:style>
-          <a:lnRef idx="1">
-            <a:schemeClr val="accent1"/>
-          </a:lnRef>
-          <a:fillRef idx="3">
-            <a:schemeClr val="accent1"/>
-          </a:fillRef>
-          <a:effectRef idx="0">
-            <a:schemeClr val="accent1"/>
-          </a:effectRef>
-          <a:fontRef idx="minor">
-            <a:schemeClr val="lt1"/>
-          </a:fontRef>
-        </p:style>
-        <p:txBody>
-          <a:bodyPr rtlCol="0" anchor="ctr"/>
-          <a:lstStyle/>
-          <a:p>
-            <a:pPr algn="ctr"/>
-          </a:p>
-        </p:txBody>
-      </p:sp>
-      <p:sp>
-        <p:nvSpPr>
-          <p:cNvPr id="19" name="TextBox 18"/>
-          <p:cNvSpPr txBox="1"/>
-          <p:nvPr/>
-        </p:nvSpPr>
-        <p:spPr>
-          <a:xfrm>
             <a:off x="850392" y="5742432"/>
             <a:ext cx="10469880" cy="292608"/>
           </a:xfrm>
@@ -7727,14 +7433,14 @@
               </a:defRPr>
             </a:pPr>
             <a:r>
-              <a:t>Which workflow would be the most useful starting point for this internship?</a:t>
-            </a:r>
-          </a:p>
-        </p:txBody>
-      </p:sp>
-      <p:sp>
-        <p:nvSpPr>
-          <p:cNvPr id="20" name="TextBox 19"/>
+              <a:t>A warning prompts review. Passing tests is not a guarantee of legal accuracy.</a:t>
+            </a:r>
+          </a:p>
+        </p:txBody>
+      </p:sp>
+      <p:sp>
+        <p:nvSpPr>
+          <p:cNvPr id="17" name="TextBox 16"/>
           <p:cNvSpPr txBox="1"/>
           <p:nvPr/>
         </p:nvSpPr>

</xml_diff>

<commit_message>
Replace challenge narrative with explicit design choices and tradeoffs
</commit_message>
<xml_diff>
--- a/presentation/Nafis_Ismam_Docitalis_Final.pptx
+++ b/presentation/Nafis_Ismam_Docitalis_Final.pptx
@@ -929,7 +929,7 @@
           <a:lstStyle/>
           <a:p>
             <a:r>
-              <a:t>About 45 seconds. Present this as design reasoning rather than invented project history. “The demo makes three concerns visible. A compound query can fail the gate, so the controlled example tries explicit decomposition. Conflicting module choices must not silently coexist, so assembly raises an error. Citation metadata may claim a source is required even when the text omits it, so the review checks actual markers.” These are chosen failure modes and scripted checks, not evidence of a real customer incident or measured business improvement. The search is not validated on natural legal queries, legal exclusions require domain approval, and marker checks do not assess semantic support. Do not claim an optimal threshold or a fully solved legal retrieval problem.</a:t>
+              <a:t>About 60 seconds. This slide replaces a challenge story with the actual implementation choices. First, 0.80 was adopted from the reference approach to demonstrate gating, not derived from experiments on this TF-IDF index. It is not 80% confidence, correctness or coverage. Calibrate thresholds with reviewed legal questions and expected sources. Second, lists and dictionaries serve different roles: a list holds multiple records, while each dictionary names fields; source["act_name"] is clearer than remembering positional indexes. The by_id dictionary also supports lookup by source ID and rejects duplicates. Third, sorted JSON plus SHA-256 produces compact fingerprints for comparing knowledge-base content and outputs. Direct equality comparisons are another option. Hashes do not themselves create determinism, establish semantic correctness, or make this an approval/signature system. Fourth, scikit-learn supplies TF-IDF and cosine similarity for a small local retrieval baseline. It needs no embedding-model download or API key. It may miss paraphrases and its score is lexical similarity, not applicability. A dense embedding model or hybrid retrieval could be evaluated later. An LLM is a separate generator/reviewer, not a direct alternative to the TF-IDF retrieval component. The current notebook uses rule-based checks rather than an LLM review layer.</a:t>
             </a:r>
           </a:p>
         </p:txBody>
@@ -10270,7 +10270,7 @@
               </a:defRPr>
             </a:pPr>
             <a:r>
-              <a:t>DESIGN RATIONALE · CHALLENGES DEMONSTRATED</a:t>
+              <a:t>DESIGN CHOICES · REASONS AND LIMITS</a:t>
             </a:r>
           </a:p>
         </p:txBody>
@@ -10309,7 +10309,7 @@
               </a:defRPr>
             </a:pPr>
             <a:r>
-              <a:t>What could go wrong—and how the demo responds</a:t>
+              <a:t>Why these choices for a small prototype?</a:t>
             </a:r>
           </a:p>
         </p:txBody>
@@ -10348,105 +10348,29 @@
               </a:defRPr>
             </a:pPr>
             <a:r>
-              <a:t>These are design concerns and scripted observations, not a real-client incident.</a:t>
-            </a:r>
-          </a:p>
-        </p:txBody>
-      </p:sp>
-      <p:sp>
-        <p:nvSpPr>
-          <p:cNvPr id="5" name="TextBox 4"/>
-          <p:cNvSpPr txBox="1"/>
-          <p:nvPr/>
-        </p:nvSpPr>
-        <p:spPr>
-          <a:xfrm>
-            <a:off x="594360" y="6519672"/>
-            <a:ext cx="9966960" cy="182880"/>
-          </a:xfrm>
-          <a:prstGeom prst="rect">
-            <a:avLst/>
-          </a:prstGeom>
-          <a:noFill/>
-        </p:spPr>
-        <p:txBody>
-          <a:bodyPr wrap="square" lIns="0" rIns="0" tIns="0" bIns="0">
-            <a:spAutoFit/>
-          </a:bodyPr>
-          <a:lstStyle/>
-          <a:p>
-            <a:pPr>
-              <a:spcAft>
-                <a:spcPts val="500"/>
-              </a:spcAft>
-              <a:defRPr sz="800" b="0">
-                <a:solidFill>
-                  <a:srgbClr val="62798A"/>
-                </a:solidFill>
-                <a:latin typeface="DejaVu Sans"/>
-              </a:defRPr>
-            </a:pPr>
-            <a:r>
-              <a:t>Proposed improvements based on the brief and demo limitations, not verified shortcomings in the existing company system.</a:t>
-            </a:r>
-          </a:p>
-        </p:txBody>
-      </p:sp>
-      <p:sp>
-        <p:nvSpPr>
-          <p:cNvPr id="6" name="TextBox 5"/>
-          <p:cNvSpPr txBox="1"/>
-          <p:nvPr/>
-        </p:nvSpPr>
-        <p:spPr>
-          <a:xfrm>
-            <a:off x="10835640" y="6446520"/>
-            <a:ext cx="731520" cy="274320"/>
-          </a:xfrm>
-          <a:prstGeom prst="rect">
-            <a:avLst/>
-          </a:prstGeom>
-          <a:noFill/>
-        </p:spPr>
-        <p:txBody>
-          <a:bodyPr wrap="square" lIns="0" rIns="0" tIns="0" bIns="0">
-            <a:spAutoFit/>
-          </a:bodyPr>
-          <a:lstStyle/>
-          <a:p>
-            <a:pPr>
-              <a:spcAft>
-                <a:spcPts val="500"/>
-              </a:spcAft>
-              <a:defRPr sz="1000" b="0">
-                <a:solidFill>
-                  <a:srgbClr val="62798A"/>
-                </a:solidFill>
-                <a:latin typeface="DejaVu Sans"/>
-              </a:defRPr>
-            </a:pPr>
-            <a:r>
-              <a:t>07 / 08</a:t>
-            </a:r>
-          </a:p>
-        </p:txBody>
-      </p:sp>
-      <p:sp>
-        <p:nvSpPr>
-          <p:cNvPr id="7" name="Rectangle 6"/>
+              <a:t>Simple tools make the behaviour easier to inspect. Each choice has a limit.</a:t>
+            </a:r>
+          </a:p>
+        </p:txBody>
+      </p:sp>
+      <p:sp>
+        <p:nvSpPr>
+          <p:cNvPr id="5" name="Rounded Rectangle 4"/>
           <p:cNvSpPr/>
           <p:nvPr/>
         </p:nvSpPr>
         <p:spPr>
           <a:xfrm>
-            <a:off x="594360" y="2706624"/>
-            <a:ext cx="11000232" cy="393192"/>
-          </a:xfrm>
-          <a:prstGeom prst="rect">
-            <a:avLst/>
+            <a:off x="594360" y="2734056"/>
+            <a:ext cx="5202936" cy="1426464"/>
+          </a:xfrm>
+          <a:prstGeom prst="roundRect">
+            <a:avLst>
+              <a:gd name="adj" fmla="val 6000"/>
+            </a:avLst>
           </a:prstGeom>
           <a:solidFill>
-            <a:srgbClr val="142C43"/>
+            <a:srgbClr val="F0F4F6"/>
           </a:solidFill>
           <a:ln>
             <a:noFill/>
@@ -10476,137 +10400,116 @@
       </p:sp>
       <p:sp>
         <p:nvSpPr>
-          <p:cNvPr id="8" name="TextBox 7"/>
-          <p:cNvSpPr txBox="1"/>
-          <p:nvPr/>
-        </p:nvSpPr>
-        <p:spPr>
-          <a:xfrm>
-            <a:off x="795528" y="2807208"/>
-            <a:ext cx="2834640" cy="219456"/>
-          </a:xfrm>
-          <a:prstGeom prst="rect">
-            <a:avLst/>
-          </a:prstGeom>
-          <a:noFill/>
-        </p:spPr>
-        <p:txBody>
-          <a:bodyPr wrap="square" lIns="0" rIns="0" tIns="0" bIns="0">
-            <a:spAutoFit/>
-          </a:bodyPr>
-          <a:lstStyle/>
-          <a:p>
-            <a:pPr>
-              <a:spcAft>
-                <a:spcPts val="500"/>
-              </a:spcAft>
-              <a:defRPr sz="1000" b="1">
-                <a:solidFill>
-                  <a:srgbClr val="FFFFFF"/>
-                </a:solidFill>
-                <a:latin typeface="DejaVu Sans"/>
-              </a:defRPr>
-            </a:pPr>
-            <a:r>
-              <a:t>CHALLENGE</a:t>
-            </a:r>
-          </a:p>
-        </p:txBody>
-      </p:sp>
-      <p:sp>
-        <p:nvSpPr>
-          <p:cNvPr id="9" name="TextBox 8"/>
-          <p:cNvSpPr txBox="1"/>
-          <p:nvPr/>
-        </p:nvSpPr>
-        <p:spPr>
-          <a:xfrm>
-            <a:off x="3858768" y="2807208"/>
-            <a:ext cx="3657600" cy="219456"/>
-          </a:xfrm>
-          <a:prstGeom prst="rect">
-            <a:avLst/>
-          </a:prstGeom>
-          <a:noFill/>
-        </p:spPr>
-        <p:txBody>
-          <a:bodyPr wrap="square" lIns="0" rIns="0" tIns="0" bIns="0">
-            <a:spAutoFit/>
-          </a:bodyPr>
-          <a:lstStyle/>
-          <a:p>
-            <a:pPr>
-              <a:spcAft>
-                <a:spcPts val="500"/>
-              </a:spcAft>
-              <a:defRPr sz="1000" b="1">
-                <a:solidFill>
-                  <a:srgbClr val="FFFFFF"/>
-                </a:solidFill>
-                <a:latin typeface="DejaVu Sans"/>
-              </a:defRPr>
-            </a:pPr>
-            <a:r>
-              <a:t>APPROACH</a:t>
-            </a:r>
-          </a:p>
-        </p:txBody>
-      </p:sp>
-      <p:sp>
-        <p:nvSpPr>
-          <p:cNvPr id="10" name="TextBox 9"/>
-          <p:cNvSpPr txBox="1"/>
-          <p:nvPr/>
-        </p:nvSpPr>
-        <p:spPr>
-          <a:xfrm>
-            <a:off x="7854696" y="2807208"/>
-            <a:ext cx="3520440" cy="219456"/>
-          </a:xfrm>
-          <a:prstGeom prst="rect">
-            <a:avLst/>
-          </a:prstGeom>
-          <a:noFill/>
-        </p:spPr>
-        <p:txBody>
-          <a:bodyPr wrap="square" lIns="0" rIns="0" tIns="0" bIns="0">
-            <a:spAutoFit/>
-          </a:bodyPr>
-          <a:lstStyle/>
-          <a:p>
-            <a:pPr>
-              <a:spcAft>
-                <a:spcPts val="500"/>
-              </a:spcAft>
-              <a:defRPr sz="1000" b="1">
-                <a:solidFill>
-                  <a:srgbClr val="FFFFFF"/>
-                </a:solidFill>
-                <a:latin typeface="DejaVu Sans"/>
-              </a:defRPr>
-            </a:pPr>
-            <a:r>
-              <a:t>REMAINING LIMIT</a:t>
-            </a:r>
-          </a:p>
-        </p:txBody>
-      </p:sp>
-      <p:sp>
-        <p:nvSpPr>
-          <p:cNvPr id="11" name="Rectangle 10"/>
+          <p:cNvPr id="6" name="TextBox 5"/>
+          <p:cNvSpPr txBox="1"/>
+          <p:nvPr/>
+        </p:nvSpPr>
+        <p:spPr>
+          <a:xfrm>
+            <a:off x="832104" y="2944368"/>
+            <a:ext cx="4727448" cy="320040"/>
+          </a:xfrm>
+          <a:prstGeom prst="rect">
+            <a:avLst/>
+          </a:prstGeom>
+          <a:noFill/>
+        </p:spPr>
+        <p:txBody>
+          <a:bodyPr wrap="square" lIns="0" rIns="0" tIns="0" bIns="0">
+            <a:spAutoFit/>
+          </a:bodyPr>
+          <a:lstStyle/>
+          <a:p>
+            <a:pPr>
+              <a:spcAft>
+                <a:spcPts val="500"/>
+              </a:spcAft>
+              <a:defRPr sz="1300" b="1">
+                <a:solidFill>
+                  <a:srgbClr val="087F76"/>
+                </a:solidFill>
+                <a:latin typeface="DejaVu Sans"/>
+              </a:defRPr>
+            </a:pPr>
+            <a:r>
+              <a:t>0.80 THRESHOLD</a:t>
+            </a:r>
+          </a:p>
+        </p:txBody>
+      </p:sp>
+      <p:sp>
+        <p:nvSpPr>
+          <p:cNvPr id="7" name="TextBox 6"/>
+          <p:cNvSpPr txBox="1"/>
+          <p:nvPr/>
+        </p:nvSpPr>
+        <p:spPr>
+          <a:xfrm>
+            <a:off x="832104" y="3456432"/>
+            <a:ext cx="4727448" cy="594360"/>
+          </a:xfrm>
+          <a:prstGeom prst="rect">
+            <a:avLst/>
+          </a:prstGeom>
+          <a:noFill/>
+        </p:spPr>
+        <p:txBody>
+          <a:bodyPr wrap="square" lIns="0" rIns="0" tIns="0" bIns="0">
+            <a:spAutoFit/>
+          </a:bodyPr>
+          <a:lstStyle/>
+          <a:p>
+            <a:pPr>
+              <a:spcAft>
+                <a:spcPts val="500"/>
+              </a:spcAft>
+              <a:defRPr sz="1400" b="0">
+                <a:solidFill>
+                  <a:srgbClr val="21394D"/>
+                </a:solidFill>
+                <a:latin typeface="DejaVu Sans"/>
+              </a:defRPr>
+            </a:pPr>
+            <a:r>
+              <a:t>A starting value from the reference approach.</a:t>
+            </a:r>
+          </a:p>
+          <a:p>
+            <a:pPr>
+              <a:spcAft>
+                <a:spcPts val="500"/>
+              </a:spcAft>
+              <a:defRPr sz="1400" b="0">
+                <a:solidFill>
+                  <a:srgbClr val="21394D"/>
+                </a:solidFill>
+                <a:latin typeface="DejaVu Sans"/>
+              </a:defRPr>
+            </a:pPr>
+            <a:r>
+              <a:t>Not calibrated here; not 80% accuracy.</a:t>
+            </a:r>
+          </a:p>
+        </p:txBody>
+      </p:sp>
+      <p:sp>
+        <p:nvSpPr>
+          <p:cNvPr id="8" name="Rounded Rectangle 7"/>
           <p:cNvSpPr/>
           <p:nvPr/>
         </p:nvSpPr>
         <p:spPr>
           <a:xfrm>
-            <a:off x="594360" y="3127248"/>
-            <a:ext cx="11000232" cy="740664"/>
-          </a:xfrm>
-          <a:prstGeom prst="rect">
-            <a:avLst/>
+            <a:off x="6391656" y="2734056"/>
+            <a:ext cx="5202936" cy="1426464"/>
+          </a:xfrm>
+          <a:prstGeom prst="roundRect">
+            <a:avLst>
+              <a:gd name="adj" fmla="val 6000"/>
+            </a:avLst>
           </a:prstGeom>
           <a:solidFill>
-            <a:srgbClr val="F0F4F6"/>
+            <a:srgbClr val="E9F4F0"/>
           </a:solidFill>
           <a:ln>
             <a:noFill/>
@@ -10636,14 +10539,14 @@
       </p:sp>
       <p:sp>
         <p:nvSpPr>
-          <p:cNvPr id="12" name="TextBox 11"/>
-          <p:cNvSpPr txBox="1"/>
-          <p:nvPr/>
-        </p:nvSpPr>
-        <p:spPr>
-          <a:xfrm>
-            <a:off x="795528" y="3273552"/>
-            <a:ext cx="2834640" cy="548640"/>
+          <p:cNvPr id="9" name="TextBox 8"/>
+          <p:cNvSpPr txBox="1"/>
+          <p:nvPr/>
+        </p:nvSpPr>
+        <p:spPr>
+          <a:xfrm>
+            <a:off x="6629400" y="2944368"/>
+            <a:ext cx="4727448" cy="320040"/>
           </a:xfrm>
           <a:prstGeom prst="rect">
             <a:avLst/>
@@ -10662,44 +10565,60 @@
               </a:spcAft>
               <a:defRPr sz="1300" b="1">
                 <a:solidFill>
+                  <a:srgbClr val="087F76"/>
+                </a:solidFill>
+                <a:latin typeface="DejaVu Sans"/>
+              </a:defRPr>
+            </a:pPr>
+            <a:r>
+              <a:t>DICTIONARIES + LISTS</a:t>
+            </a:r>
+          </a:p>
+        </p:txBody>
+      </p:sp>
+      <p:sp>
+        <p:nvSpPr>
+          <p:cNvPr id="10" name="TextBox 9"/>
+          <p:cNvSpPr txBox="1"/>
+          <p:nvPr/>
+        </p:nvSpPr>
+        <p:spPr>
+          <a:xfrm>
+            <a:off x="6629400" y="3456432"/>
+            <a:ext cx="4727448" cy="594360"/>
+          </a:xfrm>
+          <a:prstGeom prst="rect">
+            <a:avLst/>
+          </a:prstGeom>
+          <a:noFill/>
+        </p:spPr>
+        <p:txBody>
+          <a:bodyPr wrap="square" lIns="0" rIns="0" tIns="0" bIns="0">
+            <a:spAutoFit/>
+          </a:bodyPr>
+          <a:lstStyle/>
+          <a:p>
+            <a:pPr>
+              <a:spcAft>
+                <a:spcPts val="500"/>
+              </a:spcAft>
+              <a:defRPr sz="1400" b="0">
+                <a:solidFill>
                   <a:srgbClr val="21394D"/>
                 </a:solidFill>
                 <a:latin typeface="DejaVu Sans"/>
               </a:defRPr>
             </a:pPr>
             <a:r>
-              <a:t>A compound query falls below the gate</a:t>
-            </a:r>
-          </a:p>
-        </p:txBody>
-      </p:sp>
-      <p:sp>
-        <p:nvSpPr>
-          <p:cNvPr id="13" name="TextBox 12"/>
-          <p:cNvSpPr txBox="1"/>
-          <p:nvPr/>
-        </p:nvSpPr>
-        <p:spPr>
-          <a:xfrm>
-            <a:off x="3858768" y="3273552"/>
-            <a:ext cx="3657600" cy="548640"/>
-          </a:xfrm>
-          <a:prstGeom prst="rect">
-            <a:avLst/>
-          </a:prstGeom>
-          <a:noFill/>
-        </p:spPr>
-        <p:txBody>
-          <a:bodyPr wrap="square" lIns="0" rIns="0" tIns="0" bIns="0">
-            <a:spAutoFit/>
-          </a:bodyPr>
-          <a:lstStyle/>
-          <a:p>
-            <a:pPr>
-              <a:spcAft>
-                <a:spcPts val="500"/>
-              </a:spcAft>
-              <a:defRPr sz="1300" b="0">
+              <a:t>Lists hold the records; dictionaries name fields.</a:t>
+            </a:r>
+          </a:p>
+          <a:p>
+            <a:pPr>
+              <a:spcAft>
+                <a:spcPts val="500"/>
+              </a:spcAft>
+              <a:defRPr sz="1400" b="0">
                 <a:solidFill>
                   <a:srgbClr val="21394D"/>
                 </a:solidFill>
@@ -10707,66 +10626,29 @@
               </a:defRPr>
             </a:pPr>
             <a:r>
-              <a:t>Split explicit issues and search each part</a:t>
-            </a:r>
-          </a:p>
-        </p:txBody>
-      </p:sp>
-      <p:sp>
-        <p:nvSpPr>
-          <p:cNvPr id="14" name="TextBox 13"/>
-          <p:cNvSpPr txBox="1"/>
-          <p:nvPr/>
-        </p:nvSpPr>
-        <p:spPr>
-          <a:xfrm>
-            <a:off x="7854696" y="3273552"/>
-            <a:ext cx="3520440" cy="548640"/>
-          </a:xfrm>
-          <a:prstGeom prst="rect">
-            <a:avLst/>
-          </a:prstGeom>
-          <a:noFill/>
-        </p:spPr>
-        <p:txBody>
-          <a:bodyPr wrap="square" lIns="0" rIns="0" tIns="0" bIns="0">
-            <a:spAutoFit/>
-          </a:bodyPr>
-          <a:lstStyle/>
-          <a:p>
-            <a:pPr>
-              <a:spcAft>
-                <a:spcPts val="500"/>
-              </a:spcAft>
-              <a:defRPr sz="1200" b="0">
-                <a:solidFill>
-                  <a:srgbClr val="62798A"/>
-                </a:solidFill>
-                <a:latin typeface="DejaVu Sans"/>
-              </a:defRPr>
-            </a:pPr>
-            <a:r>
-              <a:t>Exact-text demo only; threshold not calibrated</a:t>
-            </a:r>
-          </a:p>
-        </p:txBody>
-      </p:sp>
-      <p:sp>
-        <p:nvSpPr>
-          <p:cNvPr id="15" name="Rectangle 14"/>
+              <a:t>Read source["act_name"], not source[1].</a:t>
+            </a:r>
+          </a:p>
+        </p:txBody>
+      </p:sp>
+      <p:sp>
+        <p:nvSpPr>
+          <p:cNvPr id="11" name="Rounded Rectangle 10"/>
           <p:cNvSpPr/>
           <p:nvPr/>
         </p:nvSpPr>
         <p:spPr>
           <a:xfrm>
-            <a:off x="594360" y="3895344"/>
-            <a:ext cx="11000232" cy="740664"/>
-          </a:xfrm>
-          <a:prstGeom prst="rect">
-            <a:avLst/>
+            <a:off x="594360" y="4398264"/>
+            <a:ext cx="5202936" cy="1426464"/>
+          </a:xfrm>
+          <a:prstGeom prst="roundRect">
+            <a:avLst>
+              <a:gd name="adj" fmla="val 6000"/>
+            </a:avLst>
           </a:prstGeom>
           <a:solidFill>
-            <a:srgbClr val="FFFFFF"/>
+            <a:srgbClr val="F0F4F6"/>
           </a:solidFill>
           <a:ln>
             <a:noFill/>
@@ -10796,14 +10678,14 @@
       </p:sp>
       <p:sp>
         <p:nvSpPr>
-          <p:cNvPr id="16" name="TextBox 15"/>
-          <p:cNvSpPr txBox="1"/>
-          <p:nvPr/>
-        </p:nvSpPr>
-        <p:spPr>
-          <a:xfrm>
-            <a:off x="795528" y="4041648"/>
-            <a:ext cx="2834640" cy="548640"/>
+          <p:cNvPr id="12" name="TextBox 11"/>
+          <p:cNvSpPr txBox="1"/>
+          <p:nvPr/>
+        </p:nvSpPr>
+        <p:spPr>
+          <a:xfrm>
+            <a:off x="832104" y="4608576"/>
+            <a:ext cx="4727448" cy="320040"/>
           </a:xfrm>
           <a:prstGeom prst="rect">
             <a:avLst/>
@@ -10822,44 +10704,60 @@
               </a:spcAft>
               <a:defRPr sz="1300" b="1">
                 <a:solidFill>
+                  <a:srgbClr val="087F76"/>
+                </a:solidFill>
+                <a:latin typeface="DejaVu Sans"/>
+              </a:defRPr>
+            </a:pPr>
+            <a:r>
+              <a:t>SHA-256 FINGERPRINTS</a:t>
+            </a:r>
+          </a:p>
+        </p:txBody>
+      </p:sp>
+      <p:sp>
+        <p:nvSpPr>
+          <p:cNvPr id="13" name="TextBox 12"/>
+          <p:cNvSpPr txBox="1"/>
+          <p:nvPr/>
+        </p:nvSpPr>
+        <p:spPr>
+          <a:xfrm>
+            <a:off x="832104" y="5120640"/>
+            <a:ext cx="4727448" cy="594360"/>
+          </a:xfrm>
+          <a:prstGeom prst="rect">
+            <a:avLst/>
+          </a:prstGeom>
+          <a:noFill/>
+        </p:spPr>
+        <p:txBody>
+          <a:bodyPr wrap="square" lIns="0" rIns="0" tIns="0" bIns="0">
+            <a:spAutoFit/>
+          </a:bodyPr>
+          <a:lstStyle/>
+          <a:p>
+            <a:pPr>
+              <a:spcAft>
+                <a:spcPts val="500"/>
+              </a:spcAft>
+              <a:defRPr sz="1400" b="0">
+                <a:solidFill>
                   <a:srgbClr val="21394D"/>
                 </a:solidFill>
                 <a:latin typeface="DejaVu Sans"/>
               </a:defRPr>
             </a:pPr>
             <a:r>
-              <a:t>Conflicting routes are selected</a:t>
-            </a:r>
-          </a:p>
-        </p:txBody>
-      </p:sp>
-      <p:sp>
-        <p:nvSpPr>
-          <p:cNvPr id="17" name="TextBox 16"/>
-          <p:cNvSpPr txBox="1"/>
-          <p:nvPr/>
-        </p:nvSpPr>
-        <p:spPr>
-          <a:xfrm>
-            <a:off x="3858768" y="4041648"/>
-            <a:ext cx="3657600" cy="548640"/>
-          </a:xfrm>
-          <a:prstGeom prst="rect">
-            <a:avLst/>
-          </a:prstGeom>
-          <a:noFill/>
-        </p:spPr>
-        <p:txBody>
-          <a:bodyPr wrap="square" lIns="0" rIns="0" tIns="0" bIns="0">
-            <a:spAutoFit/>
-          </a:bodyPr>
-          <a:lstStyle/>
-          <a:p>
-            <a:pPr>
-              <a:spcAft>
-                <a:spcPts val="500"/>
-              </a:spcAft>
-              <a:defRPr sz="1300" b="0">
+              <a:t>Compare rule and output content compactly.</a:t>
+            </a:r>
+          </a:p>
+          <a:p>
+            <a:pPr>
+              <a:spcAft>
+                <a:spcPts val="500"/>
+              </a:spcAft>
+              <a:defRPr sz="1400" b="0">
                 <a:solidFill>
                   <a:srgbClr val="21394D"/>
                 </a:solidFill>
@@ -10867,66 +10765,29 @@
               </a:defRPr>
             </a:pPr>
             <a:r>
-              <a:t>Stop before drafting; return a clear error</a:t>
-            </a:r>
-          </a:p>
-        </p:txBody>
-      </p:sp>
-      <p:sp>
-        <p:nvSpPr>
-          <p:cNvPr id="18" name="TextBox 17"/>
-          <p:cNvSpPr txBox="1"/>
-          <p:nvPr/>
-        </p:nvSpPr>
-        <p:spPr>
-          <a:xfrm>
-            <a:off x="7854696" y="4041648"/>
-            <a:ext cx="3520440" cy="548640"/>
-          </a:xfrm>
-          <a:prstGeom prst="rect">
-            <a:avLst/>
-          </a:prstGeom>
-          <a:noFill/>
-        </p:spPr>
-        <p:txBody>
-          <a:bodyPr wrap="square" lIns="0" rIns="0" tIns="0" bIns="0">
-            <a:spAutoFit/>
-          </a:bodyPr>
-          <a:lstStyle/>
-          <a:p>
-            <a:pPr>
-              <a:spcAft>
-                <a:spcPts val="500"/>
-              </a:spcAft>
-              <a:defRPr sz="1200" b="0">
-                <a:solidFill>
-                  <a:srgbClr val="62798A"/>
-                </a:solidFill>
-                <a:latin typeface="DejaVu Sans"/>
-              </a:defRPr>
-            </a:pPr>
-            <a:r>
-              <a:t>Real exclusions need lawyer approval</a:t>
-            </a:r>
-          </a:p>
-        </p:txBody>
-      </p:sp>
-      <p:sp>
-        <p:nvSpPr>
-          <p:cNvPr id="19" name="Rectangle 18"/>
+              <a:t>They do not prove legal correctness.</a:t>
+            </a:r>
+          </a:p>
+        </p:txBody>
+      </p:sp>
+      <p:sp>
+        <p:nvSpPr>
+          <p:cNvPr id="14" name="Rounded Rectangle 13"/>
           <p:cNvSpPr/>
           <p:nvPr/>
         </p:nvSpPr>
         <p:spPr>
           <a:xfrm>
-            <a:off x="594360" y="4663440"/>
-            <a:ext cx="11000232" cy="740664"/>
-          </a:xfrm>
-          <a:prstGeom prst="rect">
-            <a:avLst/>
+            <a:off x="6391656" y="4398264"/>
+            <a:ext cx="5202936" cy="1426464"/>
+          </a:xfrm>
+          <a:prstGeom prst="roundRect">
+            <a:avLst>
+              <a:gd name="adj" fmla="val 6000"/>
+            </a:avLst>
           </a:prstGeom>
           <a:solidFill>
-            <a:srgbClr val="F0F4F6"/>
+            <a:srgbClr val="E9F4F0"/>
           </a:solidFill>
           <a:ln>
             <a:noFill/>
@@ -10956,14 +10817,14 @@
       </p:sp>
       <p:sp>
         <p:nvSpPr>
-          <p:cNvPr id="20" name="TextBox 19"/>
-          <p:cNvSpPr txBox="1"/>
-          <p:nvPr/>
-        </p:nvSpPr>
-        <p:spPr>
-          <a:xfrm>
-            <a:off x="795528" y="4809744"/>
-            <a:ext cx="2834640" cy="548640"/>
+          <p:cNvPr id="15" name="TextBox 14"/>
+          <p:cNvSpPr txBox="1"/>
+          <p:nvPr/>
+        </p:nvSpPr>
+        <p:spPr>
+          <a:xfrm>
+            <a:off x="6629400" y="4608576"/>
+            <a:ext cx="4727448" cy="320040"/>
           </a:xfrm>
           <a:prstGeom prst="rect">
             <a:avLst/>
@@ -10982,44 +10843,60 @@
               </a:spcAft>
               <a:defRPr sz="1300" b="1">
                 <a:solidFill>
+                  <a:srgbClr val="087F76"/>
+                </a:solidFill>
+                <a:latin typeface="DejaVu Sans"/>
+              </a:defRPr>
+            </a:pPr>
+            <a:r>
+              <a:t>TF-IDF WITH SCIKIT-LEARN</a:t>
+            </a:r>
+          </a:p>
+        </p:txBody>
+      </p:sp>
+      <p:sp>
+        <p:nvSpPr>
+          <p:cNvPr id="16" name="TextBox 15"/>
+          <p:cNvSpPr txBox="1"/>
+          <p:nvPr/>
+        </p:nvSpPr>
+        <p:spPr>
+          <a:xfrm>
+            <a:off x="6629400" y="5120640"/>
+            <a:ext cx="4727448" cy="594360"/>
+          </a:xfrm>
+          <a:prstGeom prst="rect">
+            <a:avLst/>
+          </a:prstGeom>
+          <a:noFill/>
+        </p:spPr>
+        <p:txBody>
+          <a:bodyPr wrap="square" lIns="0" rIns="0" tIns="0" bIns="0">
+            <a:spAutoFit/>
+          </a:bodyPr>
+          <a:lstStyle/>
+          <a:p>
+            <a:pPr>
+              <a:spcAft>
+                <a:spcPts val="500"/>
+              </a:spcAft>
+              <a:defRPr sz="1400" b="0">
+                <a:solidFill>
                   <a:srgbClr val="21394D"/>
                 </a:solidFill>
                 <a:latin typeface="DejaVu Sans"/>
               </a:defRPr>
             </a:pPr>
             <a:r>
-              <a:t>A citation is missing or unknown</a:t>
-            </a:r>
-          </a:p>
-        </p:txBody>
-      </p:sp>
-      <p:sp>
-        <p:nvSpPr>
-          <p:cNvPr id="21" name="TextBox 20"/>
-          <p:cNvSpPr txBox="1"/>
-          <p:nvPr/>
-        </p:nvSpPr>
-        <p:spPr>
-          <a:xfrm>
-            <a:off x="3858768" y="4809744"/>
-            <a:ext cx="3657600" cy="548640"/>
-          </a:xfrm>
-          <a:prstGeom prst="rect">
-            <a:avLst/>
-          </a:prstGeom>
-          <a:noFill/>
-        </p:spPr>
-        <p:txBody>
-          <a:bodyPr wrap="square" lIns="0" rIns="0" tIns="0" bIns="0">
-            <a:spAutoFit/>
-          </a:bodyPr>
-          <a:lstStyle/>
-          <a:p>
-            <a:pPr>
-              <a:spcAft>
-                <a:spcPts val="500"/>
-              </a:spcAft>
-              <a:defRPr sz="1300" b="0">
+              <a:t>Lightweight word-based search; no model download.</a:t>
+            </a:r>
+          </a:p>
+          <a:p>
+            <a:pPr>
+              <a:spcAft>
+                <a:spcPts val="500"/>
+              </a:spcAft>
+              <a:defRPr sz="1400" b="0">
                 <a:solidFill>
                   <a:srgbClr val="21394D"/>
                 </a:solidFill>
@@ -11027,21 +10904,21 @@
               </a:defRPr>
             </a:pPr>
             <a:r>
-              <a:t>Compare required IDs with actual text markers</a:t>
-            </a:r>
-          </a:p>
-        </p:txBody>
-      </p:sp>
-      <p:sp>
-        <p:nvSpPr>
-          <p:cNvPr id="22" name="TextBox 21"/>
-          <p:cNvSpPr txBox="1"/>
-          <p:nvPr/>
-        </p:nvSpPr>
-        <p:spPr>
-          <a:xfrm>
-            <a:off x="7854696" y="4809744"/>
-            <a:ext cx="3520440" cy="548640"/>
+              <a:t>Simple to inspect, but weak on some paraphrases.</a:t>
+            </a:r>
+          </a:p>
+        </p:txBody>
+      </p:sp>
+      <p:sp>
+        <p:nvSpPr>
+          <p:cNvPr id="17" name="TextBox 16"/>
+          <p:cNvSpPr txBox="1"/>
+          <p:nvPr/>
+        </p:nvSpPr>
+        <p:spPr>
+          <a:xfrm>
+            <a:off x="594360" y="6099048"/>
+            <a:ext cx="10972800" cy="274320"/>
           </a:xfrm>
           <a:prstGeom prst="rect">
             <a:avLst/>
@@ -11066,91 +10943,85 @@
               </a:defRPr>
             </a:pPr>
             <a:r>
-              <a:t>Marker presence does not prove support</a:t>
-            </a:r>
-          </a:p>
-        </p:txBody>
-      </p:sp>
-      <p:sp>
-        <p:nvSpPr>
-          <p:cNvPr id="23" name="Rounded Rectangle 22"/>
-          <p:cNvSpPr/>
-          <p:nvPr/>
-        </p:nvSpPr>
-        <p:spPr>
-          <a:xfrm>
-            <a:off x="594360" y="5806440"/>
-            <a:ext cx="11000232" cy="438912"/>
-          </a:xfrm>
-          <a:prstGeom prst="roundRect">
-            <a:avLst>
-              <a:gd name="adj" fmla="val 6000"/>
-            </a:avLst>
-          </a:prstGeom>
-          <a:solidFill>
-            <a:srgbClr val="E9F4F0"/>
-          </a:solidFill>
-          <a:ln>
-            <a:noFill/>
-          </a:ln>
-        </p:spPr>
-        <p:style>
-          <a:lnRef idx="1">
-            <a:schemeClr val="accent1"/>
-          </a:lnRef>
-          <a:fillRef idx="3">
-            <a:schemeClr val="accent1"/>
-          </a:fillRef>
-          <a:effectRef idx="0">
-            <a:schemeClr val="accent1"/>
-          </a:effectRef>
-          <a:fontRef idx="minor">
-            <a:schemeClr val="lt1"/>
-          </a:fontRef>
-        </p:style>
-        <p:txBody>
-          <a:bodyPr rtlCol="0" anchor="ctr"/>
-          <a:lstStyle/>
-          <a:p>
-            <a:pPr algn="ctr"/>
-          </a:p>
-        </p:txBody>
-      </p:sp>
-      <p:sp>
-        <p:nvSpPr>
-          <p:cNvPr id="24" name="TextBox 23"/>
-          <p:cNvSpPr txBox="1"/>
-          <p:nvPr/>
-        </p:nvSpPr>
-        <p:spPr>
-          <a:xfrm>
-            <a:off x="813816" y="5925312"/>
-            <a:ext cx="10561320" cy="237744"/>
-          </a:xfrm>
-          <a:prstGeom prst="rect">
-            <a:avLst/>
-          </a:prstGeom>
-          <a:noFill/>
-        </p:spPr>
-        <p:txBody>
-          <a:bodyPr wrap="square" lIns="0" rIns="0" tIns="0" bIns="0">
-            <a:spAutoFit/>
-          </a:bodyPr>
-          <a:lstStyle/>
-          <a:p>
-            <a:pPr>
-              <a:spcAft>
-                <a:spcPts val="500"/>
-              </a:spcAft>
-              <a:defRPr sz="1400" b="1">
-                <a:solidFill>
-                  <a:srgbClr val="087F76"/>
-                </a:solidFill>
-                <a:latin typeface="DejaVu Sans"/>
-              </a:defRPr>
-            </a:pPr>
-            <a:r>
-              <a:t>Next step: validate these choices on reviewed cases and realistic legal questions.</a:t>
+              <a:t>TF-IDF retrieves text. An LLM generates or reviews text. These are different jobs.</a:t>
+            </a:r>
+          </a:p>
+        </p:txBody>
+      </p:sp>
+      <p:sp>
+        <p:nvSpPr>
+          <p:cNvPr id="18" name="TextBox 17"/>
+          <p:cNvSpPr txBox="1"/>
+          <p:nvPr/>
+        </p:nvSpPr>
+        <p:spPr>
+          <a:xfrm>
+            <a:off x="594360" y="6519672"/>
+            <a:ext cx="9966960" cy="182880"/>
+          </a:xfrm>
+          <a:prstGeom prst="rect">
+            <a:avLst/>
+          </a:prstGeom>
+          <a:noFill/>
+        </p:spPr>
+        <p:txBody>
+          <a:bodyPr wrap="square" lIns="0" rIns="0" tIns="0" bIns="0">
+            <a:spAutoFit/>
+          </a:bodyPr>
+          <a:lstStyle/>
+          <a:p>
+            <a:pPr>
+              <a:spcAft>
+                <a:spcPts val="500"/>
+              </a:spcAft>
+              <a:defRPr sz="800" b="0">
+                <a:solidFill>
+                  <a:srgbClr val="62798A"/>
+                </a:solidFill>
+                <a:latin typeface="DejaVu Sans"/>
+              </a:defRPr>
+            </a:pPr>
+            <a:r>
+              <a:t>Design choices in the current demonstration. Threshold selection still requires evaluation on representative queries.</a:t>
+            </a:r>
+          </a:p>
+        </p:txBody>
+      </p:sp>
+      <p:sp>
+        <p:nvSpPr>
+          <p:cNvPr id="19" name="TextBox 18"/>
+          <p:cNvSpPr txBox="1"/>
+          <p:nvPr/>
+        </p:nvSpPr>
+        <p:spPr>
+          <a:xfrm>
+            <a:off x="10835640" y="6446520"/>
+            <a:ext cx="731520" cy="274320"/>
+          </a:xfrm>
+          <a:prstGeom prst="rect">
+            <a:avLst/>
+          </a:prstGeom>
+          <a:noFill/>
+        </p:spPr>
+        <p:txBody>
+          <a:bodyPr wrap="square" lIns="0" rIns="0" tIns="0" bIns="0">
+            <a:spAutoFit/>
+          </a:bodyPr>
+          <a:lstStyle/>
+          <a:p>
+            <a:pPr>
+              <a:spcAft>
+                <a:spcPts val="500"/>
+              </a:spcAft>
+              <a:defRPr sz="1000" b="0">
+                <a:solidFill>
+                  <a:srgbClr val="62798A"/>
+                </a:solidFill>
+                <a:latin typeface="DejaVu Sans"/>
+              </a:defRPr>
+            </a:pPr>
+            <a:r>
+              <a:t>07 / 08</a:t>
             </a:r>
           </a:p>
         </p:txBody>

</xml_diff>

<commit_message>
Explain two implementation decisions and retain only PPTX and PDF deck files
</commit_message>
<xml_diff>
--- a/presentation/Nafis_Ismam_Docitalis_Final.pptx
+++ b/presentation/Nafis_Ismam_Docitalis_Final.pptx
@@ -929,7 +929,7 @@
           <a:lstStyle/>
           <a:p>
             <a:r>
-              <a:t>About 60 seconds. This slide replaces a challenge story with the actual implementation choices. First, 0.80 was adopted from the reference approach to demonstrate gating, not derived from experiments on this TF-IDF index. It is not 80% confidence, correctness or coverage. Calibrate thresholds with reviewed legal questions and expected sources. Second, lists and dictionaries serve different roles: a list holds multiple records, while each dictionary names fields; source["act_name"] is clearer than remembering positional indexes. The by_id dictionary also supports lookup by source ID and rejects duplicates. Third, sorted JSON plus SHA-256 produces compact fingerprints for comparing knowledge-base content and outputs. Direct equality comparisons are another option. Hashes do not themselves create determinism, establish semantic correctness, or make this an approval/signature system. Fourth, scikit-learn supplies TF-IDF and cosine similarity for a small local retrieval baseline. It needs no embedding-model download or API key. It may miss paraphrases and its score is lexical similarity, not applicability. A dense embedding model or hybrid retrieval could be evaluated later. An LLM is a separate generator/reviewer, not a direct alternative to the TF-IDF retrieval component. The current notebook uses rule-based checks rather than an LLM review layer.</a:t>
+              <a:t>About 60 seconds. Explain these as design decisions in this demonstration, not a fabricated development incident. First: distinguish a metric from its cutoff. Cosine similarity compares TF-IDF vector directions; tau=0.80 decides which scores are accepted. The threshold came from the reference approach as an illustrative starting point, not an experimental optimum for this corpus. It does not mean 80% accuracy, confidence or question coverage. Scores below the gate lead to decomposition when possible, then unresolved queries if parts still fail. Calibrate with reviewed legal questions and expected sources. Second: a consistent-looking draft can still change unexpectedly after rules are edited. The demo compares explicit expected module/citation lists on four synthetic fixtures and uses SHA-256 fingerprints to check 25 repeated full outputs. Dictionaries are converted to sorted-key JSON so key order does not alter fingerprints. Direct equality is also possible; hashes are compact content identifiers, not legal correctness checks. Tests must distinguish an intentional approved update from a regression. Real deployment would require genuinely approved examples, source verification and review. These decisions follow the requested prototype requirements; do not claim an invented production incident or independent empirical threshold selection.</a:t>
             </a:r>
           </a:p>
         </p:txBody>
@@ -10270,7 +10270,7 @@
               </a:defRPr>
             </a:pPr>
             <a:r>
-              <a:t>DESIGN CHOICES · REASONS AND LIMITS</a:t>
+              <a:t>IMPLEMENTATION DECISIONS · CHOICES AND LIMITS</a:t>
             </a:r>
           </a:p>
         </p:txBody>
@@ -10309,7 +10309,7 @@
               </a:defRPr>
             </a:pPr>
             <a:r>
-              <a:t>Why these choices for a small prototype?</a:t>
+              <a:t>Two practical questions behind the implementation</a:t>
             </a:r>
           </a:p>
         </p:txBody>
@@ -10348,7 +10348,7 @@
               </a:defRPr>
             </a:pPr>
             <a:r>
-              <a:t>Simple tools make the behaviour easier to inspect. Each choice has a limit.</a:t>
+              <a:t>What should count as a match—and how can a change be checked?</a:t>
             </a:r>
           </a:p>
         </p:txBody>
@@ -10361,8 +10361,8 @@
         </p:nvSpPr>
         <p:spPr>
           <a:xfrm>
-            <a:off x="594360" y="2734056"/>
-            <a:ext cx="5202936" cy="1426464"/>
+            <a:off x="594360" y="2706624"/>
+            <a:ext cx="11000232" cy="1426464"/>
           </a:xfrm>
           <a:prstGeom prst="roundRect">
             <a:avLst>
@@ -10406,25 +10406,25 @@
         </p:nvSpPr>
         <p:spPr>
           <a:xfrm>
-            <a:off x="832104" y="2944368"/>
-            <a:ext cx="4727448" cy="320040"/>
-          </a:xfrm>
-          <a:prstGeom prst="rect">
-            <a:avLst/>
-          </a:prstGeom>
-          <a:noFill/>
-        </p:spPr>
-        <p:txBody>
-          <a:bodyPr wrap="square" lIns="0" rIns="0" tIns="0" bIns="0">
-            <a:spAutoFit/>
-          </a:bodyPr>
-          <a:lstStyle/>
-          <a:p>
-            <a:pPr>
-              <a:spcAft>
-                <a:spcPts val="500"/>
-              </a:spcAft>
-              <a:defRPr sz="1300" b="1">
+            <a:off x="850392" y="2907792"/>
+            <a:ext cx="10488168" cy="320040"/>
+          </a:xfrm>
+          <a:prstGeom prst="rect">
+            <a:avLst/>
+          </a:prstGeom>
+          <a:noFill/>
+        </p:spPr>
+        <p:txBody>
+          <a:bodyPr wrap="square" lIns="0" rIns="0" tIns="0" bIns="0">
+            <a:spAutoFit/>
+          </a:bodyPr>
+          <a:lstStyle/>
+          <a:p>
+            <a:pPr>
+              <a:spcAft>
+                <a:spcPts val="500"/>
+              </a:spcAft>
+              <a:defRPr sz="1700" b="1">
                 <a:solidFill>
                   <a:srgbClr val="087F76"/>
                 </a:solidFill>
@@ -10432,7 +10432,7 @@
               </a:defRPr>
             </a:pPr>
             <a:r>
-              <a:t>0.80 THRESHOLD</a:t>
+              <a:t>1 · Which search results should be accepted?</a:t>
             </a:r>
           </a:p>
         </p:txBody>
@@ -10445,25 +10445,25 @@
         </p:nvSpPr>
         <p:spPr>
           <a:xfrm>
-            <a:off x="832104" y="3456432"/>
-            <a:ext cx="4727448" cy="594360"/>
-          </a:xfrm>
-          <a:prstGeom prst="rect">
-            <a:avLst/>
-          </a:prstGeom>
-          <a:noFill/>
-        </p:spPr>
-        <p:txBody>
-          <a:bodyPr wrap="square" lIns="0" rIns="0" tIns="0" bIns="0">
-            <a:spAutoFit/>
-          </a:bodyPr>
-          <a:lstStyle/>
-          <a:p>
-            <a:pPr>
-              <a:spcAft>
-                <a:spcPts val="500"/>
-              </a:spcAft>
-              <a:defRPr sz="1400" b="0">
+            <a:off x="850392" y="3502152"/>
+            <a:ext cx="5001768" cy="521207"/>
+          </a:xfrm>
+          <a:prstGeom prst="rect">
+            <a:avLst/>
+          </a:prstGeom>
+          <a:noFill/>
+        </p:spPr>
+        <p:txBody>
+          <a:bodyPr wrap="square" lIns="0" rIns="0" tIns="0" bIns="0">
+            <a:spAutoFit/>
+          </a:bodyPr>
+          <a:lstStyle/>
+          <a:p>
+            <a:pPr>
+              <a:spcAft>
+                <a:spcPts val="500"/>
+              </a:spcAft>
+              <a:defRPr sz="1300" b="0">
                 <a:solidFill>
                   <a:srgbClr val="21394D"/>
                 </a:solidFill>
@@ -10471,15 +10471,15 @@
               </a:defRPr>
             </a:pPr>
             <a:r>
-              <a:t>A starting value from the reference approach.</a:t>
-            </a:r>
-          </a:p>
-          <a:p>
-            <a:pPr>
-              <a:spcAft>
-                <a:spcPts val="500"/>
-              </a:spcAft>
-              <a:defRPr sz="1400" b="0">
+              <a:t>Metric: cosine similarity on TF-IDF vectors.</a:t>
+            </a:r>
+          </a:p>
+          <a:p>
+            <a:pPr>
+              <a:spcAft>
+                <a:spcPts val="500"/>
+              </a:spcAft>
+              <a:defRPr sz="1300" b="0">
                 <a:solidFill>
                   <a:srgbClr val="21394D"/>
                 </a:solidFill>
@@ -10487,21 +10487,76 @@
               </a:defRPr>
             </a:pPr>
             <a:r>
-              <a:t>Not calibrated here; not 80% accuracy.</a:t>
-            </a:r>
-          </a:p>
-        </p:txBody>
-      </p:sp>
-      <p:sp>
-        <p:nvSpPr>
-          <p:cNvPr id="8" name="Rounded Rectangle 7"/>
+              <a:t>Threshold: accept a score of 0.80 or higher.</a:t>
+            </a:r>
+          </a:p>
+        </p:txBody>
+      </p:sp>
+      <p:sp>
+        <p:nvSpPr>
+          <p:cNvPr id="8" name="TextBox 7"/>
+          <p:cNvSpPr txBox="1"/>
+          <p:nvPr/>
+        </p:nvSpPr>
+        <p:spPr>
+          <a:xfrm>
+            <a:off x="6400800" y="3502152"/>
+            <a:ext cx="4937760" cy="521207"/>
+          </a:xfrm>
+          <a:prstGeom prst="rect">
+            <a:avLst/>
+          </a:prstGeom>
+          <a:noFill/>
+        </p:spPr>
+        <p:txBody>
+          <a:bodyPr wrap="square" lIns="0" rIns="0" tIns="0" bIns="0">
+            <a:spAutoFit/>
+          </a:bodyPr>
+          <a:lstStyle/>
+          <a:p>
+            <a:pPr>
+              <a:spcAft>
+                <a:spcPts val="500"/>
+              </a:spcAft>
+              <a:defRPr sz="1300" b="0">
+                <a:solidFill>
+                  <a:srgbClr val="21394D"/>
+                </a:solidFill>
+                <a:latin typeface="DejaVu Sans"/>
+              </a:defRPr>
+            </a:pPr>
+            <a:r>
+              <a:t>Why: a starting value from the reference approach.</a:t>
+            </a:r>
+          </a:p>
+          <a:p>
+            <a:pPr>
+              <a:spcAft>
+                <a:spcPts val="500"/>
+              </a:spcAft>
+              <a:defRPr sz="1300" b="0">
+                <a:solidFill>
+                  <a:srgbClr val="21394D"/>
+                </a:solidFill>
+                <a:latin typeface="DejaVu Sans"/>
+              </a:defRPr>
+            </a:pPr>
+            <a:r>
+              <a:t>Meaning: a similarity gate, not 80% accuracy.</a:t>
+            </a:r>
+          </a:p>
+        </p:txBody>
+      </p:sp>
+      <p:sp>
+        <p:nvSpPr>
+          <p:cNvPr id="9" name="Rounded Rectangle 8"/>
           <p:cNvSpPr/>
           <p:nvPr/>
         </p:nvSpPr>
         <p:spPr>
           <a:xfrm>
-            <a:off x="6391656" y="2734056"/>
-            <a:ext cx="5202936" cy="1426464"/>
+            <a:off x="594360" y="4389120"/>
+            <a:ext cx="11000232" cy="1426464"/>
           </a:xfrm>
           <a:prstGeom prst="roundRect">
             <a:avLst>
@@ -10539,31 +10594,31 @@
       </p:sp>
       <p:sp>
         <p:nvSpPr>
-          <p:cNvPr id="9" name="TextBox 8"/>
-          <p:cNvSpPr txBox="1"/>
-          <p:nvPr/>
-        </p:nvSpPr>
-        <p:spPr>
-          <a:xfrm>
-            <a:off x="6629400" y="2944368"/>
-            <a:ext cx="4727448" cy="320040"/>
-          </a:xfrm>
-          <a:prstGeom prst="rect">
-            <a:avLst/>
-          </a:prstGeom>
-          <a:noFill/>
-        </p:spPr>
-        <p:txBody>
-          <a:bodyPr wrap="square" lIns="0" rIns="0" tIns="0" bIns="0">
-            <a:spAutoFit/>
-          </a:bodyPr>
-          <a:lstStyle/>
-          <a:p>
-            <a:pPr>
-              <a:spcAft>
-                <a:spcPts val="500"/>
-              </a:spcAft>
-              <a:defRPr sz="1300" b="1">
+          <p:cNvPr id="10" name="TextBox 9"/>
+          <p:cNvSpPr txBox="1"/>
+          <p:nvPr/>
+        </p:nvSpPr>
+        <p:spPr>
+          <a:xfrm>
+            <a:off x="850392" y="4590288"/>
+            <a:ext cx="10488168" cy="320040"/>
+          </a:xfrm>
+          <a:prstGeom prst="rect">
+            <a:avLst/>
+          </a:prstGeom>
+          <a:noFill/>
+        </p:spPr>
+        <p:txBody>
+          <a:bodyPr wrap="square" lIns="0" rIns="0" tIns="0" bIns="0">
+            <a:spAutoFit/>
+          </a:bodyPr>
+          <a:lstStyle/>
+          <a:p>
+            <a:pPr>
+              <a:spcAft>
+                <a:spcPts val="500"/>
+              </a:spcAft>
+              <a:defRPr sz="1700" b="1">
                 <a:solidFill>
                   <a:srgbClr val="087F76"/>
                 </a:solidFill>
@@ -10571,38 +10626,38 @@
               </a:defRPr>
             </a:pPr>
             <a:r>
-              <a:t>DICTIONARIES + LISTS</a:t>
-            </a:r>
-          </a:p>
-        </p:txBody>
-      </p:sp>
-      <p:sp>
-        <p:nvSpPr>
-          <p:cNvPr id="10" name="TextBox 9"/>
-          <p:cNvSpPr txBox="1"/>
-          <p:nvPr/>
-        </p:nvSpPr>
-        <p:spPr>
-          <a:xfrm>
-            <a:off x="6629400" y="3456432"/>
-            <a:ext cx="4727448" cy="594360"/>
-          </a:xfrm>
-          <a:prstGeom prst="rect">
-            <a:avLst/>
-          </a:prstGeom>
-          <a:noFill/>
-        </p:spPr>
-        <p:txBody>
-          <a:bodyPr wrap="square" lIns="0" rIns="0" tIns="0" bIns="0">
-            <a:spAutoFit/>
-          </a:bodyPr>
-          <a:lstStyle/>
-          <a:p>
-            <a:pPr>
-              <a:spcAft>
-                <a:spcPts val="500"/>
-              </a:spcAft>
-              <a:defRPr sz="1400" b="0">
+              <a:t>2 · How can an unintended output change be detected?</a:t>
+            </a:r>
+          </a:p>
+        </p:txBody>
+      </p:sp>
+      <p:sp>
+        <p:nvSpPr>
+          <p:cNvPr id="11" name="TextBox 10"/>
+          <p:cNvSpPr txBox="1"/>
+          <p:nvPr/>
+        </p:nvSpPr>
+        <p:spPr>
+          <a:xfrm>
+            <a:off x="850392" y="5184648"/>
+            <a:ext cx="5001768" cy="521207"/>
+          </a:xfrm>
+          <a:prstGeom prst="rect">
+            <a:avLst/>
+          </a:prstGeom>
+          <a:noFill/>
+        </p:spPr>
+        <p:txBody>
+          <a:bodyPr wrap="square" lIns="0" rIns="0" tIns="0" bIns="0">
+            <a:spAutoFit/>
+          </a:bodyPr>
+          <a:lstStyle/>
+          <a:p>
+            <a:pPr>
+              <a:spcAft>
+                <a:spcPts val="500"/>
+              </a:spcAft>
+              <a:defRPr sz="1300" b="0">
                 <a:solidFill>
                   <a:srgbClr val="21394D"/>
                 </a:solidFill>
@@ -10610,15 +10665,15 @@
               </a:defRPr>
             </a:pPr>
             <a:r>
-              <a:t>Lists hold the records; dictionaries name fields.</a:t>
-            </a:r>
-          </a:p>
-          <a:p>
-            <a:pPr>
-              <a:spcAft>
-                <a:spcPts val="500"/>
-              </a:spcAft>
-              <a:defRPr sz="1400" b="0">
+              <a:t>Choice: fixed expected modules and citations;</a:t>
+            </a:r>
+          </a:p>
+          <a:p>
+            <a:pPr>
+              <a:spcAft>
+                <a:spcPts val="500"/>
+              </a:spcAft>
+              <a:defRPr sz="1300" b="0">
                 <a:solidFill>
                   <a:srgbClr val="21394D"/>
                 </a:solidFill>
@@ -10626,53 +10681,8 @@
               </a:defRPr>
             </a:pPr>
             <a:r>
-              <a:t>Read source["act_name"], not source[1].</a:t>
-            </a:r>
-          </a:p>
-        </p:txBody>
-      </p:sp>
-      <p:sp>
-        <p:nvSpPr>
-          <p:cNvPr id="11" name="Rounded Rectangle 10"/>
-          <p:cNvSpPr/>
-          <p:nvPr/>
-        </p:nvSpPr>
-        <p:spPr>
-          <a:xfrm>
-            <a:off x="594360" y="4398264"/>
-            <a:ext cx="5202936" cy="1426464"/>
-          </a:xfrm>
-          <a:prstGeom prst="roundRect">
-            <a:avLst>
-              <a:gd name="adj" fmla="val 6000"/>
-            </a:avLst>
-          </a:prstGeom>
-          <a:solidFill>
-            <a:srgbClr val="F0F4F6"/>
-          </a:solidFill>
-          <a:ln>
-            <a:noFill/>
-          </a:ln>
-        </p:spPr>
-        <p:style>
-          <a:lnRef idx="1">
-            <a:schemeClr val="accent1"/>
-          </a:lnRef>
-          <a:fillRef idx="3">
-            <a:schemeClr val="accent1"/>
-          </a:fillRef>
-          <a:effectRef idx="0">
-            <a:schemeClr val="accent1"/>
-          </a:effectRef>
-          <a:fontRef idx="minor">
-            <a:schemeClr val="lt1"/>
-          </a:fontRef>
-        </p:style>
-        <p:txBody>
-          <a:bodyPr rtlCol="0" anchor="ctr"/>
-          <a:lstStyle/>
-          <a:p>
-            <a:pPr algn="ctr"/>
+              <a:t>SHA-256 fingerprints for repeated outputs.</a:t>
+            </a:r>
           </a:p>
         </p:txBody>
       </p:sp>
@@ -10684,33 +10694,49 @@
         </p:nvSpPr>
         <p:spPr>
           <a:xfrm>
-            <a:off x="832104" y="4608576"/>
-            <a:ext cx="4727448" cy="320040"/>
-          </a:xfrm>
-          <a:prstGeom prst="rect">
-            <a:avLst/>
-          </a:prstGeom>
-          <a:noFill/>
-        </p:spPr>
-        <p:txBody>
-          <a:bodyPr wrap="square" lIns="0" rIns="0" tIns="0" bIns="0">
-            <a:spAutoFit/>
-          </a:bodyPr>
-          <a:lstStyle/>
-          <a:p>
-            <a:pPr>
-              <a:spcAft>
-                <a:spcPts val="500"/>
-              </a:spcAft>
-              <a:defRPr sz="1300" b="1">
-                <a:solidFill>
-                  <a:srgbClr val="087F76"/>
-                </a:solidFill>
-                <a:latin typeface="DejaVu Sans"/>
-              </a:defRPr>
-            </a:pPr>
-            <a:r>
-              <a:t>SHA-256 FINGERPRINTS</a:t>
+            <a:off x="6400800" y="5184648"/>
+            <a:ext cx="4937760" cy="521207"/>
+          </a:xfrm>
+          <a:prstGeom prst="rect">
+            <a:avLst/>
+          </a:prstGeom>
+          <a:noFill/>
+        </p:spPr>
+        <p:txBody>
+          <a:bodyPr wrap="square" lIns="0" rIns="0" tIns="0" bIns="0">
+            <a:spAutoFit/>
+          </a:bodyPr>
+          <a:lstStyle/>
+          <a:p>
+            <a:pPr>
+              <a:spcAft>
+                <a:spcPts val="500"/>
+              </a:spcAft>
+              <a:defRPr sz="1300" b="0">
+                <a:solidFill>
+                  <a:srgbClr val="21394D"/>
+                </a:solidFill>
+                <a:latin typeface="DejaVu Sans"/>
+              </a:defRPr>
+            </a:pPr>
+            <a:r>
+              <a:t>Why: do not rely on rereading each draft alone.</a:t>
+            </a:r>
+          </a:p>
+          <a:p>
+            <a:pPr>
+              <a:spcAft>
+                <a:spcPts val="500"/>
+              </a:spcAft>
+              <a:defRPr sz="1300" b="0">
+                <a:solidFill>
+                  <a:srgbClr val="21394D"/>
+                </a:solidFill>
+                <a:latin typeface="DejaVu Sans"/>
+              </a:defRPr>
+            </a:pPr>
+            <a:r>
+              <a:t>Meaning: detect differences, not prove legal correctness.</a:t>
             </a:r>
           </a:p>
         </p:txBody>
@@ -10723,201 +10749,7 @@
         </p:nvSpPr>
         <p:spPr>
           <a:xfrm>
-            <a:off x="832104" y="5120640"/>
-            <a:ext cx="4727448" cy="594360"/>
-          </a:xfrm>
-          <a:prstGeom prst="rect">
-            <a:avLst/>
-          </a:prstGeom>
-          <a:noFill/>
-        </p:spPr>
-        <p:txBody>
-          <a:bodyPr wrap="square" lIns="0" rIns="0" tIns="0" bIns="0">
-            <a:spAutoFit/>
-          </a:bodyPr>
-          <a:lstStyle/>
-          <a:p>
-            <a:pPr>
-              <a:spcAft>
-                <a:spcPts val="500"/>
-              </a:spcAft>
-              <a:defRPr sz="1400" b="0">
-                <a:solidFill>
-                  <a:srgbClr val="21394D"/>
-                </a:solidFill>
-                <a:latin typeface="DejaVu Sans"/>
-              </a:defRPr>
-            </a:pPr>
-            <a:r>
-              <a:t>Compare rule and output content compactly.</a:t>
-            </a:r>
-          </a:p>
-          <a:p>
-            <a:pPr>
-              <a:spcAft>
-                <a:spcPts val="500"/>
-              </a:spcAft>
-              <a:defRPr sz="1400" b="0">
-                <a:solidFill>
-                  <a:srgbClr val="21394D"/>
-                </a:solidFill>
-                <a:latin typeface="DejaVu Sans"/>
-              </a:defRPr>
-            </a:pPr>
-            <a:r>
-              <a:t>They do not prove legal correctness.</a:t>
-            </a:r>
-          </a:p>
-        </p:txBody>
-      </p:sp>
-      <p:sp>
-        <p:nvSpPr>
-          <p:cNvPr id="14" name="Rounded Rectangle 13"/>
-          <p:cNvSpPr/>
-          <p:nvPr/>
-        </p:nvSpPr>
-        <p:spPr>
-          <a:xfrm>
-            <a:off x="6391656" y="4398264"/>
-            <a:ext cx="5202936" cy="1426464"/>
-          </a:xfrm>
-          <a:prstGeom prst="roundRect">
-            <a:avLst>
-              <a:gd name="adj" fmla="val 6000"/>
-            </a:avLst>
-          </a:prstGeom>
-          <a:solidFill>
-            <a:srgbClr val="E9F4F0"/>
-          </a:solidFill>
-          <a:ln>
-            <a:noFill/>
-          </a:ln>
-        </p:spPr>
-        <p:style>
-          <a:lnRef idx="1">
-            <a:schemeClr val="accent1"/>
-          </a:lnRef>
-          <a:fillRef idx="3">
-            <a:schemeClr val="accent1"/>
-          </a:fillRef>
-          <a:effectRef idx="0">
-            <a:schemeClr val="accent1"/>
-          </a:effectRef>
-          <a:fontRef idx="minor">
-            <a:schemeClr val="lt1"/>
-          </a:fontRef>
-        </p:style>
-        <p:txBody>
-          <a:bodyPr rtlCol="0" anchor="ctr"/>
-          <a:lstStyle/>
-          <a:p>
-            <a:pPr algn="ctr"/>
-          </a:p>
-        </p:txBody>
-      </p:sp>
-      <p:sp>
-        <p:nvSpPr>
-          <p:cNvPr id="15" name="TextBox 14"/>
-          <p:cNvSpPr txBox="1"/>
-          <p:nvPr/>
-        </p:nvSpPr>
-        <p:spPr>
-          <a:xfrm>
-            <a:off x="6629400" y="4608576"/>
-            <a:ext cx="4727448" cy="320040"/>
-          </a:xfrm>
-          <a:prstGeom prst="rect">
-            <a:avLst/>
-          </a:prstGeom>
-          <a:noFill/>
-        </p:spPr>
-        <p:txBody>
-          <a:bodyPr wrap="square" lIns="0" rIns="0" tIns="0" bIns="0">
-            <a:spAutoFit/>
-          </a:bodyPr>
-          <a:lstStyle/>
-          <a:p>
-            <a:pPr>
-              <a:spcAft>
-                <a:spcPts val="500"/>
-              </a:spcAft>
-              <a:defRPr sz="1300" b="1">
-                <a:solidFill>
-                  <a:srgbClr val="087F76"/>
-                </a:solidFill>
-                <a:latin typeface="DejaVu Sans"/>
-              </a:defRPr>
-            </a:pPr>
-            <a:r>
-              <a:t>TF-IDF WITH SCIKIT-LEARN</a:t>
-            </a:r>
-          </a:p>
-        </p:txBody>
-      </p:sp>
-      <p:sp>
-        <p:nvSpPr>
-          <p:cNvPr id="16" name="TextBox 15"/>
-          <p:cNvSpPr txBox="1"/>
-          <p:nvPr/>
-        </p:nvSpPr>
-        <p:spPr>
-          <a:xfrm>
-            <a:off x="6629400" y="5120640"/>
-            <a:ext cx="4727448" cy="594360"/>
-          </a:xfrm>
-          <a:prstGeom prst="rect">
-            <a:avLst/>
-          </a:prstGeom>
-          <a:noFill/>
-        </p:spPr>
-        <p:txBody>
-          <a:bodyPr wrap="square" lIns="0" rIns="0" tIns="0" bIns="0">
-            <a:spAutoFit/>
-          </a:bodyPr>
-          <a:lstStyle/>
-          <a:p>
-            <a:pPr>
-              <a:spcAft>
-                <a:spcPts val="500"/>
-              </a:spcAft>
-              <a:defRPr sz="1400" b="0">
-                <a:solidFill>
-                  <a:srgbClr val="21394D"/>
-                </a:solidFill>
-                <a:latin typeface="DejaVu Sans"/>
-              </a:defRPr>
-            </a:pPr>
-            <a:r>
-              <a:t>Lightweight word-based search; no model download.</a:t>
-            </a:r>
-          </a:p>
-          <a:p>
-            <a:pPr>
-              <a:spcAft>
-                <a:spcPts val="500"/>
-              </a:spcAft>
-              <a:defRPr sz="1400" b="0">
-                <a:solidFill>
-                  <a:srgbClr val="21394D"/>
-                </a:solidFill>
-                <a:latin typeface="DejaVu Sans"/>
-              </a:defRPr>
-            </a:pPr>
-            <a:r>
-              <a:t>Simple to inspect, but weak on some paraphrases.</a:t>
-            </a:r>
-          </a:p>
-        </p:txBody>
-      </p:sp>
-      <p:sp>
-        <p:nvSpPr>
-          <p:cNvPr id="17" name="TextBox 16"/>
-          <p:cNvSpPr txBox="1"/>
-          <p:nvPr/>
-        </p:nvSpPr>
-        <p:spPr>
-          <a:xfrm>
-            <a:off x="594360" y="6099048"/>
+            <a:off x="594360" y="6089904"/>
             <a:ext cx="10972800" cy="274320"/>
           </a:xfrm>
           <a:prstGeom prst="rect">
@@ -10943,14 +10775,14 @@
               </a:defRPr>
             </a:pPr>
             <a:r>
-              <a:t>TF-IDF retrieves text. An LLM generates or reviews text. These are different jobs.</a:t>
-            </a:r>
-          </a:p>
-        </p:txBody>
-      </p:sp>
-      <p:sp>
-        <p:nvSpPr>
-          <p:cNvPr id="18" name="TextBox 17"/>
+              <a:t>Next: calibrate retrieval on realistic questions and validate expectations with lawyers.</a:t>
+            </a:r>
+          </a:p>
+        </p:txBody>
+      </p:sp>
+      <p:sp>
+        <p:nvSpPr>
+          <p:cNvPr id="14" name="TextBox 13"/>
           <p:cNvSpPr txBox="1"/>
           <p:nvPr/>
         </p:nvSpPr>
@@ -10982,14 +10814,14 @@
               </a:defRPr>
             </a:pPr>
             <a:r>
-              <a:t>Design choices in the current demonstration. Threshold selection still requires evaluation on representative queries.</a:t>
-            </a:r>
-          </a:p>
-        </p:txBody>
-      </p:sp>
-      <p:sp>
-        <p:nvSpPr>
-          <p:cNvPr id="19" name="TextBox 18"/>
+              <a:t>Design rationale for this demonstration. 0.80 is uncalibrated; reference cases and updates are synthetic.</a:t>
+            </a:r>
+          </a:p>
+        </p:txBody>
+      </p:sp>
+      <p:sp>
+        <p:nvSpPr>
+          <p:cNvPr id="15" name="TextBox 14"/>
           <p:cNvSpPr txBox="1"/>
           <p:nvPr/>
         </p:nvSpPr>

</xml_diff>

<commit_message>
Remove implementation decisions slide and renumber final deck
</commit_message>
<xml_diff>
--- a/presentation/Nafis_Ismam_Docitalis_Final.pptx
+++ b/presentation/Nafis_Ismam_Docitalis_Final.pptx
@@ -11,7 +11,6 @@
     <p:sldId id="259" r:id="rId11"/>
     <p:sldId id="260" r:id="rId12"/>
     <p:sldId id="261" r:id="rId13"/>
-    <p:sldId id="262" r:id="rId14"/>
     <p:sldId id="263" r:id="rId15"/>
   </p:sldIdLst>
   <p:sldSz cx="12191695" cy="6858000" type="screen4x3"/>
@@ -860,76 +859,6 @@
           <a:p>
             <a:r>
               <a:t>About 50 seconds. Reproducibility compares document and full-output fingerprints across 25 runs. Reference parity compares four synthetic cases against independently written module sequences, citation lists and actual text markers. The conflict test expects an exception when both teaching routes are requested, and checks consistent messages. The update test begins with no notes, adds a simulated C167 note and expects M3 and M5 warnings. Additional checks remove C54, add unknown C999 and exercise retrieval paths. All four groups pass. These checks were specified for this role-focused demonstration, not taken as an evaluation suite from the research paper. Twenty-five is a demonstration count, not a statistical guarantee. Synthetic fixtures are not genuinely lawyer-approved historical cases. Passing checks software expectations, not legal correctness.</a:t>
-            </a:r>
-          </a:p>
-        </p:txBody>
-      </p:sp>
-      <p:sp>
-        <p:nvSpPr>
-          <p:cNvPr id="4" name="Slide Number Placeholder 3"/>
-          <p:cNvSpPr>
-            <a:spLocks noGrp="1"/>
-          </p:cNvSpPr>
-          <p:nvPr>
-            <p:ph type="sldNum" idx="5" sz="quarter"/>
-          </p:nvPr>
-        </p:nvSpPr>
-        <p:spPr/>
-      </p:sp>
-    </p:spTree>
-  </p:cSld>
-  <p:clrMapOvr>
-    <a:masterClrMapping/>
-  </p:clrMapOvr>
-</p:notes>
-</file>
-
-<file path=ppt/notesSlides/notesSlide7.xml><?xml version="1.0" encoding="utf-8"?>
-<p:notes xmlns:a="http://schemas.openxmlformats.org/drawingml/2006/main" xmlns:p="http://schemas.openxmlformats.org/presentationml/2006/main" xmlns:r="http://schemas.openxmlformats.org/officeDocument/2006/relationships">
-  <p:cSld>
-    <p:spTree>
-      <p:nvGrpSpPr>
-        <p:cNvPr id="1" name=""/>
-        <p:cNvGrpSpPr/>
-        <p:nvPr/>
-      </p:nvGrpSpPr>
-      <p:grpSpPr>
-        <a:xfrm>
-          <a:off x="0" y="0"/>
-          <a:ext cx="0" cy="0"/>
-          <a:chOff x="0" y="0"/>
-          <a:chExt cx="0" cy="0"/>
-        </a:xfrm>
-      </p:grpSpPr>
-      <p:sp>
-        <p:nvSpPr>
-          <p:cNvPr id="2" name="Slide Image Placeholder 1"/>
-          <p:cNvSpPr>
-            <a:spLocks noGrp="1"/>
-          </p:cNvSpPr>
-          <p:nvPr>
-            <p:ph type="sldImg" idx="2"/>
-          </p:nvPr>
-        </p:nvSpPr>
-        <p:spPr/>
-      </p:sp>
-      <p:sp>
-        <p:nvSpPr>
-          <p:cNvPr id="3" name="Notes Placeholder 2"/>
-          <p:cNvSpPr>
-            <a:spLocks noGrp="1"/>
-          </p:cNvSpPr>
-          <p:nvPr>
-            <p:ph type="body" idx="3" sz="quarter"/>
-          </p:nvPr>
-        </p:nvSpPr>
-        <p:spPr/>
-        <p:txBody>
-          <a:bodyPr/>
-          <a:lstStyle/>
-          <a:p>
-            <a:r>
-              <a:t>About 60 seconds. Explain these as design decisions in this demonstration, not a fabricated development incident. First: distinguish a metric from its cutoff. Cosine similarity compares TF-IDF vector directions; tau=0.80 decides which scores are accepted. The threshold came from the reference approach as an illustrative starting point, not an experimental optimum for this corpus. It does not mean 80% accuracy, confidence or question coverage. Scores below the gate lead to decomposition when possible, then unresolved queries if parts still fail. Calibrate with reviewed legal questions and expected sources. Second: a consistent-looking draft can still change unexpectedly after rules are edited. The demo compares explicit expected module/citation lists on four synthetic fixtures and uses SHA-256 fingerprints to check 25 repeated full outputs. Dictionaries are converted to sorted-key JSON so key order does not alter fingerprints. Direct equality is also possible; hashes are compact content identifiers, not legal correctness checks. Tests must distinguish an intentional approved update from a regression. Real deployment would require genuinely approved examples, source verification and review. These decisions follow the requested prototype requirements; do not claim an invented production incident or independent empirical threshold selection.</a:t>
             </a:r>
           </a:p>
         </p:txBody>
@@ -4125,7 +4054,7 @@
               </a:defRPr>
             </a:pPr>
             <a:r>
-              <a:t>01 / 08</a:t>
+              <a:t>01 / 07</a:t>
             </a:r>
           </a:p>
         </p:txBody>
@@ -4880,7 +4809,7 @@
               </a:defRPr>
             </a:pPr>
             <a:r>
-              <a:t>02 / 08</a:t>
+              <a:t>02 / 07</a:t>
             </a:r>
           </a:p>
         </p:txBody>
@@ -5772,7 +5701,7 @@
               </a:defRPr>
             </a:pPr>
             <a:r>
-              <a:t>03 / 08</a:t>
+              <a:t>03 / 07</a:t>
             </a:r>
           </a:p>
         </p:txBody>
@@ -6651,7 +6580,7 @@
               </a:defRPr>
             </a:pPr>
             <a:r>
-              <a:t>04 / 08</a:t>
+              <a:t>04 / 07</a:t>
             </a:r>
           </a:p>
         </p:txBody>
@@ -8310,7 +8239,7 @@
               </a:defRPr>
             </a:pPr>
             <a:r>
-              <a:t>05 / 08</a:t>
+              <a:t>05 / 07</a:t>
             </a:r>
           </a:p>
         </p:txBody>
@@ -9366,7 +9295,7 @@
               </a:defRPr>
             </a:pPr>
             <a:r>
-              <a:t>06 / 08</a:t>
+              <a:t>06 / 07</a:t>
             </a:r>
           </a:p>
         </p:txBody>
@@ -10206,654 +10135,6 @@
             </a:pPr>
             <a:r>
               <a:t>All four groups PASS. Extra assertions check missing/unknown citations and retrieval paths.</a:t>
-            </a:r>
-          </a:p>
-        </p:txBody>
-      </p:sp>
-    </p:spTree>
-  </p:cSld>
-  <p:clrMapOvr>
-    <a:masterClrMapping/>
-  </p:clrMapOvr>
-</p:sld>
-</file>
-
-<file path=ppt/slides/slide7.xml><?xml version="1.0" encoding="utf-8"?>
-<p:sld xmlns:a="http://schemas.openxmlformats.org/drawingml/2006/main" xmlns:p="http://schemas.openxmlformats.org/presentationml/2006/main" xmlns:r="http://schemas.openxmlformats.org/officeDocument/2006/relationships">
-  <p:cSld>
-    <p:bg>
-      <p:bgPr>
-        <a:solidFill>
-          <a:srgbClr val="FFFFFF"/>
-        </a:solidFill>
-        <a:effectLst/>
-      </p:bgPr>
-    </p:bg>
-    <p:spTree>
-      <p:nvGrpSpPr>
-        <p:cNvPr id="1" name=""/>
-        <p:cNvGrpSpPr/>
-        <p:nvPr/>
-      </p:nvGrpSpPr>
-      <p:grpSpPr/>
-      <p:sp>
-        <p:nvSpPr>
-          <p:cNvPr id="2" name="TextBox 1"/>
-          <p:cNvSpPr txBox="1"/>
-          <p:nvPr/>
-        </p:nvSpPr>
-        <p:spPr>
-          <a:xfrm>
-            <a:off x="594360" y="365760"/>
-            <a:ext cx="10058400" cy="274320"/>
-          </a:xfrm>
-          <a:prstGeom prst="rect">
-            <a:avLst/>
-          </a:prstGeom>
-          <a:noFill/>
-        </p:spPr>
-        <p:txBody>
-          <a:bodyPr wrap="square" lIns="0" rIns="0" tIns="0" bIns="0">
-            <a:spAutoFit/>
-          </a:bodyPr>
-          <a:lstStyle/>
-          <a:p>
-            <a:pPr>
-              <a:spcAft>
-                <a:spcPts val="500"/>
-              </a:spcAft>
-              <a:defRPr sz="1100" b="1">
-                <a:solidFill>
-                  <a:srgbClr val="087F76"/>
-                </a:solidFill>
-                <a:latin typeface="DejaVu Sans"/>
-              </a:defRPr>
-            </a:pPr>
-            <a:r>
-              <a:t>IMPLEMENTATION DECISIONS · CHOICES AND LIMITS</a:t>
-            </a:r>
-          </a:p>
-        </p:txBody>
-      </p:sp>
-      <p:sp>
-        <p:nvSpPr>
-          <p:cNvPr id="3" name="TextBox 2"/>
-          <p:cNvSpPr txBox="1"/>
-          <p:nvPr/>
-        </p:nvSpPr>
-        <p:spPr>
-          <a:xfrm>
-            <a:off x="594360" y="950976"/>
-            <a:ext cx="10972800" cy="960120"/>
-          </a:xfrm>
-          <a:prstGeom prst="rect">
-            <a:avLst/>
-          </a:prstGeom>
-          <a:noFill/>
-        </p:spPr>
-        <p:txBody>
-          <a:bodyPr wrap="square" lIns="0" rIns="0" tIns="0" bIns="0">
-            <a:spAutoFit/>
-          </a:bodyPr>
-          <a:lstStyle/>
-          <a:p>
-            <a:pPr>
-              <a:spcAft>
-                <a:spcPts val="500"/>
-              </a:spcAft>
-              <a:defRPr sz="3000" b="1">
-                <a:solidFill>
-                  <a:srgbClr val="142C43"/>
-                </a:solidFill>
-                <a:latin typeface="DejaVu Sans"/>
-              </a:defRPr>
-            </a:pPr>
-            <a:r>
-              <a:t>Two practical questions behind the implementation</a:t>
-            </a:r>
-          </a:p>
-        </p:txBody>
-      </p:sp>
-      <p:sp>
-        <p:nvSpPr>
-          <p:cNvPr id="4" name="TextBox 3"/>
-          <p:cNvSpPr txBox="1"/>
-          <p:nvPr/>
-        </p:nvSpPr>
-        <p:spPr>
-          <a:xfrm>
-            <a:off x="594360" y="1938528"/>
-            <a:ext cx="10972800" cy="548640"/>
-          </a:xfrm>
-          <a:prstGeom prst="rect">
-            <a:avLst/>
-          </a:prstGeom>
-          <a:noFill/>
-        </p:spPr>
-        <p:txBody>
-          <a:bodyPr wrap="square" lIns="0" rIns="0" tIns="0" bIns="0">
-            <a:spAutoFit/>
-          </a:bodyPr>
-          <a:lstStyle/>
-          <a:p>
-            <a:pPr>
-              <a:spcAft>
-                <a:spcPts val="500"/>
-              </a:spcAft>
-              <a:defRPr sz="1500" b="0">
-                <a:solidFill>
-                  <a:srgbClr val="62798A"/>
-                </a:solidFill>
-                <a:latin typeface="DejaVu Sans"/>
-              </a:defRPr>
-            </a:pPr>
-            <a:r>
-              <a:t>What should count as a match—and how can a change be checked?</a:t>
-            </a:r>
-          </a:p>
-        </p:txBody>
-      </p:sp>
-      <p:sp>
-        <p:nvSpPr>
-          <p:cNvPr id="5" name="Rounded Rectangle 4"/>
-          <p:cNvSpPr/>
-          <p:nvPr/>
-        </p:nvSpPr>
-        <p:spPr>
-          <a:xfrm>
-            <a:off x="594360" y="2706624"/>
-            <a:ext cx="11000232" cy="1426464"/>
-          </a:xfrm>
-          <a:prstGeom prst="roundRect">
-            <a:avLst>
-              <a:gd name="adj" fmla="val 6000"/>
-            </a:avLst>
-          </a:prstGeom>
-          <a:solidFill>
-            <a:srgbClr val="F0F4F6"/>
-          </a:solidFill>
-          <a:ln>
-            <a:noFill/>
-          </a:ln>
-        </p:spPr>
-        <p:style>
-          <a:lnRef idx="1">
-            <a:schemeClr val="accent1"/>
-          </a:lnRef>
-          <a:fillRef idx="3">
-            <a:schemeClr val="accent1"/>
-          </a:fillRef>
-          <a:effectRef idx="0">
-            <a:schemeClr val="accent1"/>
-          </a:effectRef>
-          <a:fontRef idx="minor">
-            <a:schemeClr val="lt1"/>
-          </a:fontRef>
-        </p:style>
-        <p:txBody>
-          <a:bodyPr rtlCol="0" anchor="ctr"/>
-          <a:lstStyle/>
-          <a:p>
-            <a:pPr algn="ctr"/>
-          </a:p>
-        </p:txBody>
-      </p:sp>
-      <p:sp>
-        <p:nvSpPr>
-          <p:cNvPr id="6" name="TextBox 5"/>
-          <p:cNvSpPr txBox="1"/>
-          <p:nvPr/>
-        </p:nvSpPr>
-        <p:spPr>
-          <a:xfrm>
-            <a:off x="850392" y="2907792"/>
-            <a:ext cx="10488168" cy="320040"/>
-          </a:xfrm>
-          <a:prstGeom prst="rect">
-            <a:avLst/>
-          </a:prstGeom>
-          <a:noFill/>
-        </p:spPr>
-        <p:txBody>
-          <a:bodyPr wrap="square" lIns="0" rIns="0" tIns="0" bIns="0">
-            <a:spAutoFit/>
-          </a:bodyPr>
-          <a:lstStyle/>
-          <a:p>
-            <a:pPr>
-              <a:spcAft>
-                <a:spcPts val="500"/>
-              </a:spcAft>
-              <a:defRPr sz="1700" b="1">
-                <a:solidFill>
-                  <a:srgbClr val="087F76"/>
-                </a:solidFill>
-                <a:latin typeface="DejaVu Sans"/>
-              </a:defRPr>
-            </a:pPr>
-            <a:r>
-              <a:t>1 · Which search results should be accepted?</a:t>
-            </a:r>
-          </a:p>
-        </p:txBody>
-      </p:sp>
-      <p:sp>
-        <p:nvSpPr>
-          <p:cNvPr id="7" name="TextBox 6"/>
-          <p:cNvSpPr txBox="1"/>
-          <p:nvPr/>
-        </p:nvSpPr>
-        <p:spPr>
-          <a:xfrm>
-            <a:off x="850392" y="3502152"/>
-            <a:ext cx="5001768" cy="521207"/>
-          </a:xfrm>
-          <a:prstGeom prst="rect">
-            <a:avLst/>
-          </a:prstGeom>
-          <a:noFill/>
-        </p:spPr>
-        <p:txBody>
-          <a:bodyPr wrap="square" lIns="0" rIns="0" tIns="0" bIns="0">
-            <a:spAutoFit/>
-          </a:bodyPr>
-          <a:lstStyle/>
-          <a:p>
-            <a:pPr>
-              <a:spcAft>
-                <a:spcPts val="500"/>
-              </a:spcAft>
-              <a:defRPr sz="1300" b="0">
-                <a:solidFill>
-                  <a:srgbClr val="21394D"/>
-                </a:solidFill>
-                <a:latin typeface="DejaVu Sans"/>
-              </a:defRPr>
-            </a:pPr>
-            <a:r>
-              <a:t>Metric: cosine similarity on TF-IDF vectors.</a:t>
-            </a:r>
-          </a:p>
-          <a:p>
-            <a:pPr>
-              <a:spcAft>
-                <a:spcPts val="500"/>
-              </a:spcAft>
-              <a:defRPr sz="1300" b="0">
-                <a:solidFill>
-                  <a:srgbClr val="21394D"/>
-                </a:solidFill>
-                <a:latin typeface="DejaVu Sans"/>
-              </a:defRPr>
-            </a:pPr>
-            <a:r>
-              <a:t>Threshold: accept a score of 0.80 or higher.</a:t>
-            </a:r>
-          </a:p>
-        </p:txBody>
-      </p:sp>
-      <p:sp>
-        <p:nvSpPr>
-          <p:cNvPr id="8" name="TextBox 7"/>
-          <p:cNvSpPr txBox="1"/>
-          <p:nvPr/>
-        </p:nvSpPr>
-        <p:spPr>
-          <a:xfrm>
-            <a:off x="6400800" y="3502152"/>
-            <a:ext cx="4937760" cy="521207"/>
-          </a:xfrm>
-          <a:prstGeom prst="rect">
-            <a:avLst/>
-          </a:prstGeom>
-          <a:noFill/>
-        </p:spPr>
-        <p:txBody>
-          <a:bodyPr wrap="square" lIns="0" rIns="0" tIns="0" bIns="0">
-            <a:spAutoFit/>
-          </a:bodyPr>
-          <a:lstStyle/>
-          <a:p>
-            <a:pPr>
-              <a:spcAft>
-                <a:spcPts val="500"/>
-              </a:spcAft>
-              <a:defRPr sz="1300" b="0">
-                <a:solidFill>
-                  <a:srgbClr val="21394D"/>
-                </a:solidFill>
-                <a:latin typeface="DejaVu Sans"/>
-              </a:defRPr>
-            </a:pPr>
-            <a:r>
-              <a:t>Why: a starting value from the reference approach.</a:t>
-            </a:r>
-          </a:p>
-          <a:p>
-            <a:pPr>
-              <a:spcAft>
-                <a:spcPts val="500"/>
-              </a:spcAft>
-              <a:defRPr sz="1300" b="0">
-                <a:solidFill>
-                  <a:srgbClr val="21394D"/>
-                </a:solidFill>
-                <a:latin typeface="DejaVu Sans"/>
-              </a:defRPr>
-            </a:pPr>
-            <a:r>
-              <a:t>Meaning: a similarity gate, not 80% accuracy.</a:t>
-            </a:r>
-          </a:p>
-        </p:txBody>
-      </p:sp>
-      <p:sp>
-        <p:nvSpPr>
-          <p:cNvPr id="9" name="Rounded Rectangle 8"/>
-          <p:cNvSpPr/>
-          <p:nvPr/>
-        </p:nvSpPr>
-        <p:spPr>
-          <a:xfrm>
-            <a:off x="594360" y="4389120"/>
-            <a:ext cx="11000232" cy="1426464"/>
-          </a:xfrm>
-          <a:prstGeom prst="roundRect">
-            <a:avLst>
-              <a:gd name="adj" fmla="val 6000"/>
-            </a:avLst>
-          </a:prstGeom>
-          <a:solidFill>
-            <a:srgbClr val="E9F4F0"/>
-          </a:solidFill>
-          <a:ln>
-            <a:noFill/>
-          </a:ln>
-        </p:spPr>
-        <p:style>
-          <a:lnRef idx="1">
-            <a:schemeClr val="accent1"/>
-          </a:lnRef>
-          <a:fillRef idx="3">
-            <a:schemeClr val="accent1"/>
-          </a:fillRef>
-          <a:effectRef idx="0">
-            <a:schemeClr val="accent1"/>
-          </a:effectRef>
-          <a:fontRef idx="minor">
-            <a:schemeClr val="lt1"/>
-          </a:fontRef>
-        </p:style>
-        <p:txBody>
-          <a:bodyPr rtlCol="0" anchor="ctr"/>
-          <a:lstStyle/>
-          <a:p>
-            <a:pPr algn="ctr"/>
-          </a:p>
-        </p:txBody>
-      </p:sp>
-      <p:sp>
-        <p:nvSpPr>
-          <p:cNvPr id="10" name="TextBox 9"/>
-          <p:cNvSpPr txBox="1"/>
-          <p:nvPr/>
-        </p:nvSpPr>
-        <p:spPr>
-          <a:xfrm>
-            <a:off x="850392" y="4590288"/>
-            <a:ext cx="10488168" cy="320040"/>
-          </a:xfrm>
-          <a:prstGeom prst="rect">
-            <a:avLst/>
-          </a:prstGeom>
-          <a:noFill/>
-        </p:spPr>
-        <p:txBody>
-          <a:bodyPr wrap="square" lIns="0" rIns="0" tIns="0" bIns="0">
-            <a:spAutoFit/>
-          </a:bodyPr>
-          <a:lstStyle/>
-          <a:p>
-            <a:pPr>
-              <a:spcAft>
-                <a:spcPts val="500"/>
-              </a:spcAft>
-              <a:defRPr sz="1700" b="1">
-                <a:solidFill>
-                  <a:srgbClr val="087F76"/>
-                </a:solidFill>
-                <a:latin typeface="DejaVu Sans"/>
-              </a:defRPr>
-            </a:pPr>
-            <a:r>
-              <a:t>2 · How can an unintended output change be detected?</a:t>
-            </a:r>
-          </a:p>
-        </p:txBody>
-      </p:sp>
-      <p:sp>
-        <p:nvSpPr>
-          <p:cNvPr id="11" name="TextBox 10"/>
-          <p:cNvSpPr txBox="1"/>
-          <p:nvPr/>
-        </p:nvSpPr>
-        <p:spPr>
-          <a:xfrm>
-            <a:off x="850392" y="5184648"/>
-            <a:ext cx="5001768" cy="521207"/>
-          </a:xfrm>
-          <a:prstGeom prst="rect">
-            <a:avLst/>
-          </a:prstGeom>
-          <a:noFill/>
-        </p:spPr>
-        <p:txBody>
-          <a:bodyPr wrap="square" lIns="0" rIns="0" tIns="0" bIns="0">
-            <a:spAutoFit/>
-          </a:bodyPr>
-          <a:lstStyle/>
-          <a:p>
-            <a:pPr>
-              <a:spcAft>
-                <a:spcPts val="500"/>
-              </a:spcAft>
-              <a:defRPr sz="1300" b="0">
-                <a:solidFill>
-                  <a:srgbClr val="21394D"/>
-                </a:solidFill>
-                <a:latin typeface="DejaVu Sans"/>
-              </a:defRPr>
-            </a:pPr>
-            <a:r>
-              <a:t>Choice: fixed expected modules and citations;</a:t>
-            </a:r>
-          </a:p>
-          <a:p>
-            <a:pPr>
-              <a:spcAft>
-                <a:spcPts val="500"/>
-              </a:spcAft>
-              <a:defRPr sz="1300" b="0">
-                <a:solidFill>
-                  <a:srgbClr val="21394D"/>
-                </a:solidFill>
-                <a:latin typeface="DejaVu Sans"/>
-              </a:defRPr>
-            </a:pPr>
-            <a:r>
-              <a:t>SHA-256 fingerprints for repeated outputs.</a:t>
-            </a:r>
-          </a:p>
-        </p:txBody>
-      </p:sp>
-      <p:sp>
-        <p:nvSpPr>
-          <p:cNvPr id="12" name="TextBox 11"/>
-          <p:cNvSpPr txBox="1"/>
-          <p:nvPr/>
-        </p:nvSpPr>
-        <p:spPr>
-          <a:xfrm>
-            <a:off x="6400800" y="5184648"/>
-            <a:ext cx="4937760" cy="521207"/>
-          </a:xfrm>
-          <a:prstGeom prst="rect">
-            <a:avLst/>
-          </a:prstGeom>
-          <a:noFill/>
-        </p:spPr>
-        <p:txBody>
-          <a:bodyPr wrap="square" lIns="0" rIns="0" tIns="0" bIns="0">
-            <a:spAutoFit/>
-          </a:bodyPr>
-          <a:lstStyle/>
-          <a:p>
-            <a:pPr>
-              <a:spcAft>
-                <a:spcPts val="500"/>
-              </a:spcAft>
-              <a:defRPr sz="1300" b="0">
-                <a:solidFill>
-                  <a:srgbClr val="21394D"/>
-                </a:solidFill>
-                <a:latin typeface="DejaVu Sans"/>
-              </a:defRPr>
-            </a:pPr>
-            <a:r>
-              <a:t>Why: do not rely on rereading each draft alone.</a:t>
-            </a:r>
-          </a:p>
-          <a:p>
-            <a:pPr>
-              <a:spcAft>
-                <a:spcPts val="500"/>
-              </a:spcAft>
-              <a:defRPr sz="1300" b="0">
-                <a:solidFill>
-                  <a:srgbClr val="21394D"/>
-                </a:solidFill>
-                <a:latin typeface="DejaVu Sans"/>
-              </a:defRPr>
-            </a:pPr>
-            <a:r>
-              <a:t>Meaning: detect differences, not prove legal correctness.</a:t>
-            </a:r>
-          </a:p>
-        </p:txBody>
-      </p:sp>
-      <p:sp>
-        <p:nvSpPr>
-          <p:cNvPr id="13" name="TextBox 12"/>
-          <p:cNvSpPr txBox="1"/>
-          <p:nvPr/>
-        </p:nvSpPr>
-        <p:spPr>
-          <a:xfrm>
-            <a:off x="594360" y="6089904"/>
-            <a:ext cx="10972800" cy="274320"/>
-          </a:xfrm>
-          <a:prstGeom prst="rect">
-            <a:avLst/>
-          </a:prstGeom>
-          <a:noFill/>
-        </p:spPr>
-        <p:txBody>
-          <a:bodyPr wrap="square" lIns="0" rIns="0" tIns="0" bIns="0">
-            <a:spAutoFit/>
-          </a:bodyPr>
-          <a:lstStyle/>
-          <a:p>
-            <a:pPr>
-              <a:spcAft>
-                <a:spcPts val="500"/>
-              </a:spcAft>
-              <a:defRPr sz="1200" b="0">
-                <a:solidFill>
-                  <a:srgbClr val="62798A"/>
-                </a:solidFill>
-                <a:latin typeface="DejaVu Sans"/>
-              </a:defRPr>
-            </a:pPr>
-            <a:r>
-              <a:t>Next: calibrate retrieval on realistic questions and validate expectations with lawyers.</a:t>
-            </a:r>
-          </a:p>
-        </p:txBody>
-      </p:sp>
-      <p:sp>
-        <p:nvSpPr>
-          <p:cNvPr id="14" name="TextBox 13"/>
-          <p:cNvSpPr txBox="1"/>
-          <p:nvPr/>
-        </p:nvSpPr>
-        <p:spPr>
-          <a:xfrm>
-            <a:off x="594360" y="6519672"/>
-            <a:ext cx="9966960" cy="182880"/>
-          </a:xfrm>
-          <a:prstGeom prst="rect">
-            <a:avLst/>
-          </a:prstGeom>
-          <a:noFill/>
-        </p:spPr>
-        <p:txBody>
-          <a:bodyPr wrap="square" lIns="0" rIns="0" tIns="0" bIns="0">
-            <a:spAutoFit/>
-          </a:bodyPr>
-          <a:lstStyle/>
-          <a:p>
-            <a:pPr>
-              <a:spcAft>
-                <a:spcPts val="500"/>
-              </a:spcAft>
-              <a:defRPr sz="800" b="0">
-                <a:solidFill>
-                  <a:srgbClr val="62798A"/>
-                </a:solidFill>
-                <a:latin typeface="DejaVu Sans"/>
-              </a:defRPr>
-            </a:pPr>
-            <a:r>
-              <a:t>Design rationale for this demonstration. 0.80 is uncalibrated; reference cases and updates are synthetic.</a:t>
-            </a:r>
-          </a:p>
-        </p:txBody>
-      </p:sp>
-      <p:sp>
-        <p:nvSpPr>
-          <p:cNvPr id="15" name="TextBox 14"/>
-          <p:cNvSpPr txBox="1"/>
-          <p:nvPr/>
-        </p:nvSpPr>
-        <p:spPr>
-          <a:xfrm>
-            <a:off x="10835640" y="6446520"/>
-            <a:ext cx="731520" cy="274320"/>
-          </a:xfrm>
-          <a:prstGeom prst="rect">
-            <a:avLst/>
-          </a:prstGeom>
-          <a:noFill/>
-        </p:spPr>
-        <p:txBody>
-          <a:bodyPr wrap="square" lIns="0" rIns="0" tIns="0" bIns="0">
-            <a:spAutoFit/>
-          </a:bodyPr>
-          <a:lstStyle/>
-          <a:p>
-            <a:pPr>
-              <a:spcAft>
-                <a:spcPts val="500"/>
-              </a:spcAft>
-              <a:defRPr sz="1000" b="0">
-                <a:solidFill>
-                  <a:srgbClr val="62798A"/>
-                </a:solidFill>
-                <a:latin typeface="DejaVu Sans"/>
-              </a:defRPr>
-            </a:pPr>
-            <a:r>
-              <a:t>07 / 08</a:t>
             </a:r>
           </a:p>
         </p:txBody>
@@ -11074,7 +10355,7 @@
               </a:defRPr>
             </a:pPr>
             <a:r>
-              <a:t>08 / 08</a:t>
+              <a:t>07 / 07</a:t>
             </a:r>
           </a:p>
         </p:txBody>

</xml_diff>